<commit_message>
feat(round2): add Similar Past Scams retrieval from Turso & Multi-SMS Batch Mode with live matrix
</commit_message>
<xml_diff>
--- a/public/Kavach_AI_Pitch_Deck_Highlighted.pptx
+++ b/public/Kavach_AI_Pitch_Deck_Highlighted.pptx
@@ -4,6 +4,9 @@
   <p:sldMasterIdLst>
     <p:sldMasterId id="2147483648" r:id="rId1"/>
   </p:sldMasterIdLst>
+  <p:notesMasterIdLst>
+    <p:notesMasterId r:id="rId10"/>
+  </p:notesMasterIdLst>
   <p:sldIdLst>
     <p:sldId id="256" r:id="rId2"/>
     <p:sldId id="257" r:id="rId3"/>
@@ -14,10 +17,7 @@
     <p:sldId id="262" r:id="rId8"/>
     <p:sldId id="263" r:id="rId9"/>
   </p:sldIdLst>
-  <p:notesMasterIdLst>
-    <p:notesMasterId r:id="rId10"/>
-  </p:notesMasterIdLst>
-  <p:sldSz cx="9144000" cy="5143500"/>
+  <p:sldSz cx="9144000" cy="5143500" type="screen16x9"/>
   <p:notesSz cx="5143500" cy="9144000"/>
   <p:defaultTextStyle>
     <a:lvl1pPr marL="0" algn="l" defTabSz="914400" rtl="0" eaLnBrk="1" latinLnBrk="0" hangingPunct="1">
@@ -111,6 +111,11 @@
       </a:defRPr>
     </a:lvl9pPr>
   </p:defaultTextStyle>
+  <p:extLst>
+    <p:ext uri="{EFAFB233-063F-42B5-8137-9DF3F51BA10A}">
+      <p15:sldGuideLst xmlns:p15="http://schemas.microsoft.com/office/powerpoint/2012/main"/>
+    </p:ext>
+  </p:extLst>
 </p:presentation>
 </file>
 
@@ -136,234 +141,10 @@
           <a:chExt cx="0" cy="0"/>
         </a:xfrm>
       </p:grpSpPr>
-      <p:sp>
-        <p:nvSpPr>
-          <p:cNvPr id="2" name="Header Placeholder 1"/>
-          <p:cNvSpPr>
-            <a:spLocks noGrp="1"/>
-          </p:cNvSpPr>
-          <p:nvPr>
-            <p:ph type="hdr" sz="quarter"/>
-          </p:nvPr>
-        </p:nvSpPr>
-        <p:spPr>
-          <a:xfrm>
-            <a:off x="0" y="0"/>
-            <a:ext cx="2971800" cy="458788"/>
-          </a:xfrm>
-          <a:prstGeom prst="rect">
-            <a:avLst/>
-          </a:prstGeom>
-        </p:spPr>
-        <p:txBody>
-          <a:bodyPr vert="horz" lIns="91440" tIns="45720" rIns="91440" bIns="45720" rtlCol="0"/>
-          <a:lstStyle>
-            <a:lvl1pPr algn="l">
-              <a:defRPr sz="1200"/>
-            </a:lvl1pPr>
-          </a:lstStyle>
-          <a:p>
-            <a:endParaRPr lang="en-US"/>
-          </a:p>
-        </p:txBody>
-      </p:sp>
-      <p:sp>
-        <p:nvSpPr>
-          <p:cNvPr id="3" name="Date Placeholder 2"/>
-          <p:cNvSpPr>
-            <a:spLocks noGrp="1"/>
-          </p:cNvSpPr>
-          <p:nvPr>
-            <p:ph type="dt" idx="1"/>
-          </p:nvPr>
-        </p:nvSpPr>
-        <p:spPr>
-          <a:xfrm>
-            <a:off x="3884613" y="0"/>
-            <a:ext cx="2971800" cy="458788"/>
-          </a:xfrm>
-          <a:prstGeom prst="rect">
-            <a:avLst/>
-          </a:prstGeom>
-        </p:spPr>
-        <p:txBody>
-          <a:bodyPr vert="horz" lIns="91440" tIns="45720" rIns="91440" bIns="45720" rtlCol="0"/>
-          <a:lstStyle>
-            <a:lvl1pPr algn="r">
-              <a:defRPr sz="1200"/>
-            </a:lvl1pPr>
-          </a:lstStyle>
-          <a:p>
-            <a:fld id="{5282F153-3F37-0F45-9E97-73ACFA13230C}" type="datetimeFigureOut">
-              <a:rPr lang="en-US"/>
-              <a:t>7/23/19</a:t>
-            </a:fld>
-            <a:endParaRPr lang="en-US"/>
-          </a:p>
-        </p:txBody>
-      </p:sp>
-      <p:sp>
-        <p:nvSpPr>
-          <p:cNvPr id="4" name="Slide Image Placeholder 3"/>
-          <p:cNvSpPr>
-            <a:spLocks noGrp="1" noRot="1" noChangeAspect="1"/>
-          </p:cNvSpPr>
-          <p:nvPr>
-            <p:ph type="sldImg" idx="2"/>
-          </p:nvPr>
-        </p:nvSpPr>
-        <p:spPr>
-          <a:xfrm>
-            <a:off x="685800" y="1143000"/>
-            <a:ext cx="5486400" cy="3086100"/>
-          </a:xfrm>
-          <a:prstGeom prst="rect">
-            <a:avLst/>
-          </a:prstGeom>
-          <a:noFill/>
-          <a:ln w="12700">
-            <a:solidFill>
-              <a:prstClr val="black"/>
-            </a:solidFill>
-          </a:ln>
-        </p:spPr>
-        <p:txBody>
-          <a:bodyPr vert="horz" lIns="91440" tIns="45720" rIns="91440" bIns="45720" rtlCol="0" anchor="ctr"/>
-          <a:lstStyle/>
-          <a:p>
-            <a:endParaRPr lang="en-US"/>
-          </a:p>
-        </p:txBody>
-      </p:sp>
-      <p:sp>
-        <p:nvSpPr>
-          <p:cNvPr id="5" name="Notes Placeholder 4"/>
-          <p:cNvSpPr>
-            <a:spLocks noGrp="1"/>
-          </p:cNvSpPr>
-          <p:nvPr>
-            <p:ph type="body" sz="quarter" idx="3"/>
-          </p:nvPr>
-        </p:nvSpPr>
-        <p:spPr>
-          <a:xfrm>
-            <a:off x="685800" y="4400550"/>
-            <a:ext cx="5486400" cy="3600450"/>
-          </a:xfrm>
-          <a:prstGeom prst="rect">
-            <a:avLst/>
-          </a:prstGeom>
-        </p:spPr>
-        <p:txBody>
-          <a:bodyPr vert="horz" lIns="91440" tIns="45720" rIns="91440" bIns="45720" rtlCol="0"/>
-          <a:lstStyle/>
-          <a:p>
-            <a:pPr lvl="0"/>
-            <a:r>
-              <a:rPr lang="en-US"/>
-              <a:t>Click to edit Master text styles</a:t>
-            </a:r>
-          </a:p>
-          <a:p>
-            <a:pPr lvl="1"/>
-            <a:r>
-              <a:rPr lang="en-US"/>
-              <a:t>Second level</a:t>
-            </a:r>
-          </a:p>
-          <a:p>
-            <a:pPr lvl="2"/>
-            <a:r>
-              <a:rPr lang="en-US"/>
-              <a:t>Third level</a:t>
-            </a:r>
-          </a:p>
-          <a:p>
-            <a:pPr lvl="3"/>
-            <a:r>
-              <a:rPr lang="en-US"/>
-              <a:t>Fourth level</a:t>
-            </a:r>
-          </a:p>
-          <a:p>
-            <a:pPr lvl="4"/>
-            <a:r>
-              <a:rPr lang="en-US"/>
-              <a:t>Fifth level</a:t>
-            </a:r>
-          </a:p>
-        </p:txBody>
-      </p:sp>
-      <p:sp>
-        <p:nvSpPr>
-          <p:cNvPr id="6" name="Footer Placeholder 5"/>
-          <p:cNvSpPr>
-            <a:spLocks noGrp="1"/>
-          </p:cNvSpPr>
-          <p:nvPr>
-            <p:ph type="ftr" sz="quarter" idx="4"/>
-          </p:nvPr>
-        </p:nvSpPr>
-        <p:spPr>
-          <a:xfrm>
-            <a:off x="0" y="8685213"/>
-            <a:ext cx="2971800" cy="458787"/>
-          </a:xfrm>
-          <a:prstGeom prst="rect">
-            <a:avLst/>
-          </a:prstGeom>
-        </p:spPr>
-        <p:txBody>
-          <a:bodyPr vert="horz" lIns="91440" tIns="45720" rIns="91440" bIns="45720" rtlCol="0" anchor="b"/>
-          <a:lstStyle>
-            <a:lvl1pPr algn="l">
-              <a:defRPr sz="1200"/>
-            </a:lvl1pPr>
-          </a:lstStyle>
-          <a:p>
-            <a:endParaRPr lang="en-US"/>
-          </a:p>
-        </p:txBody>
-      </p:sp>
-      <p:sp>
-        <p:nvSpPr>
-          <p:cNvPr id="7" name="Slide Number Placeholder 6"/>
-          <p:cNvSpPr>
-            <a:spLocks noGrp="1"/>
-          </p:cNvSpPr>
-          <p:nvPr>
-            <p:ph type="sldNum" sz="quarter" idx="5"/>
-          </p:nvPr>
-        </p:nvSpPr>
-        <p:spPr>
-          <a:xfrm>
-            <a:off x="3884613" y="8685213"/>
-            <a:ext cx="2971800" cy="458787"/>
-          </a:xfrm>
-          <a:prstGeom prst="rect">
-            <a:avLst/>
-          </a:prstGeom>
-        </p:spPr>
-        <p:txBody>
-          <a:bodyPr vert="horz" lIns="91440" tIns="45720" rIns="91440" bIns="45720" rtlCol="0" anchor="b"/>
-          <a:lstStyle>
-            <a:lvl1pPr algn="r">
-              <a:defRPr sz="1200"/>
-            </a:lvl1pPr>
-          </a:lstStyle>
-          <a:p>
-            <a:fld id="{CE5E9CC1-C706-0F49-92D6-E571CC5EEA8F}" type="slidenum">
-              <a:rPr lang="en-US"/>
-              <a:t>‹#›</a:t>
-            </a:fld>
-            <a:endParaRPr lang="en-US"/>
-          </a:p>
-        </p:txBody>
-      </p:sp>
     </p:spTree>
     <p:extLst>
       <p:ext uri="{BB962C8B-B14F-4D97-AF65-F5344CB8AC3E}">
-        <p14:creationId xmlns:p14="http://schemas.microsoft.com/office/powerpoint/2010/main" val="1024086991"/>
+        <p14:creationId xmlns:p14="http://schemas.microsoft.com/office/powerpoint/2010/main" val="3909704413"/>
       </p:ext>
     </p:extLst>
   </p:cSld>
@@ -507,10 +288,6 @@
           <a:bodyPr/>
           <a:lstStyle/>
           <a:p>
-            <a:r>
-              <a:rPr lang="en-US" dirty="0"/>
-              <a:t/>
-            </a:r>
             <a:endParaRPr lang="en-US" dirty="0"/>
           </a:p>
         </p:txBody>
@@ -595,10 +372,6 @@
           <a:bodyPr/>
           <a:lstStyle/>
           <a:p>
-            <a:r>
-              <a:rPr lang="en-US" dirty="0"/>
-              <a:t/>
-            </a:r>
             <a:endParaRPr lang="en-US" dirty="0"/>
           </a:p>
         </p:txBody>
@@ -683,10 +456,6 @@
           <a:bodyPr/>
           <a:lstStyle/>
           <a:p>
-            <a:r>
-              <a:rPr lang="en-US" dirty="0"/>
-              <a:t/>
-            </a:r>
             <a:endParaRPr lang="en-US" dirty="0"/>
           </a:p>
         </p:txBody>
@@ -771,10 +540,6 @@
           <a:bodyPr/>
           <a:lstStyle/>
           <a:p>
-            <a:r>
-              <a:rPr lang="en-US" dirty="0"/>
-              <a:t/>
-            </a:r>
             <a:endParaRPr lang="en-US" dirty="0"/>
           </a:p>
         </p:txBody>
@@ -859,10 +624,6 @@
           <a:bodyPr/>
           <a:lstStyle/>
           <a:p>
-            <a:r>
-              <a:rPr lang="en-US" dirty="0"/>
-              <a:t/>
-            </a:r>
             <a:endParaRPr lang="en-US" dirty="0"/>
           </a:p>
         </p:txBody>
@@ -947,10 +708,6 @@
           <a:bodyPr/>
           <a:lstStyle/>
           <a:p>
-            <a:r>
-              <a:rPr lang="en-US" dirty="0"/>
-              <a:t/>
-            </a:r>
             <a:endParaRPr lang="en-US" dirty="0"/>
           </a:p>
         </p:txBody>
@@ -1035,10 +792,6 @@
           <a:bodyPr/>
           <a:lstStyle/>
           <a:p>
-            <a:r>
-              <a:rPr lang="en-US" dirty="0"/>
-              <a:t/>
-            </a:r>
             <a:endParaRPr lang="en-US" dirty="0"/>
           </a:p>
         </p:txBody>
@@ -1123,10 +876,6 @@
           <a:bodyPr/>
           <a:lstStyle/>
           <a:p>
-            <a:r>
-              <a:rPr lang="en-US" dirty="0"/>
-              <a:t/>
-            </a:r>
             <a:endParaRPr lang="en-US" dirty="0"/>
           </a:p>
         </p:txBody>
@@ -1205,6 +954,7 @@
         <a:solidFill>
           <a:srgbClr val="09090D"/>
         </a:solidFill>
+        <a:effectLst/>
       </p:bgPr>
     </p:bg>
     <p:spTree>
@@ -1268,14 +1018,14 @@
       </p:sp>
       <p:pic>
         <p:nvPicPr>
-          <p:cNvPr id="4" name="Image 0" descr="D:\hackathon_elicit_acm\assets\acm_logo.png">    </p:cNvPr>
+          <p:cNvPr id="4" name="Image 0" descr="D:\hackathon_elicit_acm\assets\acm_logo.png"/>
           <p:cNvPicPr>
             <a:picLocks noChangeAspect="1"/>
           </p:cNvPicPr>
           <p:nvPr/>
         </p:nvPicPr>
         <p:blipFill>
-          <a:blip r:embed="rId1"/>
+          <a:blip r:embed="rId2"/>
           <a:stretch>
             <a:fillRect/>
           </a:stretch>
@@ -1301,6 +1051,11 @@
 <file path=ppt/slideMasters/slideMaster1.xml><?xml version="1.0" encoding="utf-8"?>
 <p:sldMaster xmlns:a="http://schemas.openxmlformats.org/drawingml/2006/main" xmlns:r="http://schemas.openxmlformats.org/officeDocument/2006/relationships" xmlns:p="http://schemas.openxmlformats.org/presentationml/2006/main">
   <p:cSld>
+    <p:bg>
+      <p:bgRef idx="1001">
+        <a:schemeClr val="bg1"/>
+      </p:bgRef>
+    </p:bg>
     <p:spTree>
       <p:nvGrpSpPr>
         <p:cNvPr id="1" name=""/>
@@ -1605,9 +1360,7 @@
             <a:ext cx="5550408" cy="256032"/>
           </a:xfrm>
           <a:prstGeom prst="rect">
-            <a:avLst>
-              <a:gd name="adj" fmla="val 21429"/>
-            </a:avLst>
+            <a:avLst/>
           </a:prstGeom>
           <a:solidFill>
             <a:srgbClr val="241D09"/>
@@ -1641,7 +1394,7 @@
           <a:bodyPr wrap="square" lIns="0" tIns="0" rIns="0" bIns="0" rtlCol="0" anchor="ctr"/>
           <a:lstStyle/>
           <a:p>
-            <a:pPr indent="0" marL="0">
+            <a:pPr marL="0" indent="0">
               <a:buNone/>
             </a:pPr>
             <a:r>
@@ -1680,7 +1433,7 @@
           <a:bodyPr wrap="square" lIns="0" tIns="0" rIns="0" bIns="0" rtlCol="0" anchor="ctr"/>
           <a:lstStyle/>
           <a:p>
-            <a:pPr indent="0" marL="0">
+            <a:pPr marL="0" indent="0">
               <a:buNone/>
             </a:pPr>
             <a:r>
@@ -1710,9 +1463,7 @@
             <a:ext cx="6035040" cy="5120640"/>
           </a:xfrm>
           <a:prstGeom prst="rect">
-            <a:avLst>
-              <a:gd name="adj" fmla="val 714"/>
-            </a:avLst>
+            <a:avLst/>
           </a:prstGeom>
           <a:solidFill>
             <a:srgbClr val="13131D"/>
@@ -1746,7 +1497,7 @@
           <a:bodyPr wrap="square" lIns="0" tIns="0" rIns="0" bIns="0" rtlCol="0" anchor="ctr"/>
           <a:lstStyle/>
           <a:p>
-            <a:pPr indent="0" marL="0">
+            <a:pPr marL="0" indent="0">
               <a:buNone/>
             </a:pPr>
             <a:r>
@@ -1785,7 +1536,7 @@
           <a:bodyPr wrap="square" lIns="0" tIns="0" rIns="0" bIns="0" rtlCol="0" anchor="ctr"/>
           <a:lstStyle/>
           <a:p>
-            <a:pPr indent="0" marL="0">
+            <a:pPr marL="0" indent="0">
               <a:lnSpc>
                 <a:spcPts val="1200"/>
               </a:lnSpc>
@@ -1827,7 +1578,7 @@
           <a:bodyPr wrap="square" lIns="0" tIns="0" rIns="0" bIns="0" rtlCol="0" anchor="ctr"/>
           <a:lstStyle/>
           <a:p>
-            <a:pPr indent="0" marL="0">
+            <a:pPr marL="0" indent="0">
               <a:buNone/>
             </a:pPr>
             <a:r>
@@ -1866,7 +1617,7 @@
           <a:bodyPr wrap="square" lIns="0" tIns="0" rIns="0" bIns="0" rtlCol="0" anchor="ctr"/>
           <a:lstStyle/>
           <a:p>
-            <a:pPr indent="0" marL="0">
+            <a:pPr marL="0" indent="0">
               <a:lnSpc>
                 <a:spcPts val="1100"/>
               </a:lnSpc>
@@ -1899,9 +1650,7 @@
             <a:ext cx="2560320" cy="256032"/>
           </a:xfrm>
           <a:prstGeom prst="rect">
-            <a:avLst>
-              <a:gd name="adj" fmla="val 21429"/>
-            </a:avLst>
+            <a:avLst/>
           </a:prstGeom>
           <a:solidFill>
             <a:srgbClr val="241D09"/>
@@ -1935,7 +1684,7 @@
           <a:bodyPr wrap="square" lIns="0" tIns="0" rIns="0" bIns="0" rtlCol="0" anchor="ctr"/>
           <a:lstStyle/>
           <a:p>
-            <a:pPr indent="0" marL="0">
+            <a:pPr marL="0" indent="0">
               <a:buNone/>
             </a:pPr>
             <a:r>
@@ -1965,9 +1714,7 @@
             <a:ext cx="2697480" cy="1234440"/>
           </a:xfrm>
           <a:prstGeom prst="rect">
-            <a:avLst>
-              <a:gd name="adj" fmla="val 2963"/>
-            </a:avLst>
+            <a:avLst/>
           </a:prstGeom>
           <a:solidFill>
             <a:srgbClr val="181826"/>
@@ -2001,7 +1748,7 @@
           <a:bodyPr wrap="square" lIns="0" tIns="0" rIns="0" bIns="0" rtlCol="0" anchor="ctr"/>
           <a:lstStyle/>
           <a:p>
-            <a:pPr indent="0" marL="0">
+            <a:pPr marL="0" indent="0">
               <a:buNone/>
             </a:pPr>
             <a:r>
@@ -2040,7 +1787,7 @@
           <a:bodyPr wrap="square" lIns="0" tIns="0" rIns="0" bIns="0" rtlCol="0" anchor="ctr"/>
           <a:lstStyle/>
           <a:p>
-            <a:pPr indent="0" marL="0">
+            <a:pPr marL="0" indent="0">
               <a:buNone/>
             </a:pPr>
             <a:r>
@@ -2079,7 +1826,7 @@
           <a:bodyPr wrap="square" lIns="0" tIns="0" rIns="0" bIns="0" rtlCol="0" anchor="ctr"/>
           <a:lstStyle/>
           <a:p>
-            <a:pPr indent="0" marL="0">
+            <a:pPr marL="0" indent="0">
               <a:buNone/>
             </a:pPr>
             <a:r>
@@ -2109,9 +1856,7 @@
             <a:ext cx="2697480" cy="1234440"/>
           </a:xfrm>
           <a:prstGeom prst="rect">
-            <a:avLst>
-              <a:gd name="adj" fmla="val 2963"/>
-            </a:avLst>
+            <a:avLst/>
           </a:prstGeom>
           <a:solidFill>
             <a:srgbClr val="181826"/>
@@ -2145,7 +1890,7 @@
           <a:bodyPr wrap="square" lIns="0" tIns="0" rIns="0" bIns="0" rtlCol="0" anchor="ctr"/>
           <a:lstStyle/>
           <a:p>
-            <a:pPr indent="0" marL="0">
+            <a:pPr marL="0" indent="0">
               <a:buNone/>
             </a:pPr>
             <a:r>
@@ -2184,7 +1929,7 @@
           <a:bodyPr wrap="square" lIns="0" tIns="0" rIns="0" bIns="0" rtlCol="0" anchor="ctr"/>
           <a:lstStyle/>
           <a:p>
-            <a:pPr indent="0" marL="0">
+            <a:pPr marL="0" indent="0">
               <a:buNone/>
             </a:pPr>
             <a:r>
@@ -2223,7 +1968,7 @@
           <a:bodyPr wrap="square" lIns="0" tIns="0" rIns="0" bIns="0" rtlCol="0" anchor="ctr"/>
           <a:lstStyle/>
           <a:p>
-            <a:pPr indent="0" marL="0">
+            <a:pPr marL="0" indent="0">
               <a:buNone/>
             </a:pPr>
             <a:r>
@@ -2253,9 +1998,7 @@
             <a:ext cx="2697480" cy="1234440"/>
           </a:xfrm>
           <a:prstGeom prst="rect">
-            <a:avLst>
-              <a:gd name="adj" fmla="val 2963"/>
-            </a:avLst>
+            <a:avLst/>
           </a:prstGeom>
           <a:solidFill>
             <a:srgbClr val="181826"/>
@@ -2289,7 +2032,7 @@
           <a:bodyPr wrap="square" lIns="0" tIns="0" rIns="0" bIns="0" rtlCol="0" anchor="ctr"/>
           <a:lstStyle/>
           <a:p>
-            <a:pPr indent="0" marL="0">
+            <a:pPr marL="0" indent="0">
               <a:buNone/>
             </a:pPr>
             <a:r>
@@ -2328,7 +2071,7 @@
           <a:bodyPr wrap="square" lIns="0" tIns="0" rIns="0" bIns="0" rtlCol="0" anchor="ctr"/>
           <a:lstStyle/>
           <a:p>
-            <a:pPr indent="0" marL="0">
+            <a:pPr marL="0" indent="0">
               <a:buNone/>
             </a:pPr>
             <a:r>
@@ -2367,7 +2110,7 @@
           <a:bodyPr wrap="square" lIns="0" tIns="0" rIns="0" bIns="0" rtlCol="0" anchor="ctr"/>
           <a:lstStyle/>
           <a:p>
-            <a:pPr indent="0" marL="0">
+            <a:pPr marL="0" indent="0">
               <a:buNone/>
             </a:pPr>
             <a:r>
@@ -2397,9 +2140,7 @@
             <a:ext cx="2697480" cy="1234440"/>
           </a:xfrm>
           <a:prstGeom prst="rect">
-            <a:avLst>
-              <a:gd name="adj" fmla="val 2963"/>
-            </a:avLst>
+            <a:avLst/>
           </a:prstGeom>
           <a:solidFill>
             <a:srgbClr val="181826"/>
@@ -2433,7 +2174,7 @@
           <a:bodyPr wrap="square" lIns="0" tIns="0" rIns="0" bIns="0" rtlCol="0" anchor="ctr"/>
           <a:lstStyle/>
           <a:p>
-            <a:pPr indent="0" marL="0">
+            <a:pPr marL="0" indent="0">
               <a:buNone/>
             </a:pPr>
             <a:r>
@@ -2472,7 +2213,7 @@
           <a:bodyPr wrap="square" lIns="0" tIns="0" rIns="0" bIns="0" rtlCol="0" anchor="ctr"/>
           <a:lstStyle/>
           <a:p>
-            <a:pPr indent="0" marL="0">
+            <a:pPr marL="0" indent="0">
               <a:buNone/>
             </a:pPr>
             <a:r>
@@ -2511,7 +2252,7 @@
           <a:bodyPr wrap="square" lIns="0" tIns="0" rIns="0" bIns="0" rtlCol="0" anchor="ctr"/>
           <a:lstStyle/>
           <a:p>
-            <a:pPr indent="0" marL="0">
+            <a:pPr marL="0" indent="0">
               <a:buNone/>
             </a:pPr>
             <a:r>
@@ -2541,9 +2282,7 @@
             <a:ext cx="4873752" cy="5120640"/>
           </a:xfrm>
           <a:prstGeom prst="rect">
-            <a:avLst>
-              <a:gd name="adj" fmla="val 750"/>
-            </a:avLst>
+            <a:avLst/>
           </a:prstGeom>
           <a:solidFill>
             <a:srgbClr val="13131D"/>
@@ -2558,15 +2297,15 @@
       </p:sp>
       <p:pic>
         <p:nvPicPr>
-          <p:cNvPr id="29" name="Image 0" descr="D:\hackathon_elicit_acm\assets\hero_metrics.png">    </p:cNvPr>
+          <p:cNvPr id="29" name="Image 0" descr="D:\hackathon_elicit_acm\assets\hero_metrics.png"/>
           <p:cNvPicPr>
             <a:picLocks noChangeAspect="1"/>
           </p:cNvPicPr>
           <p:nvPr/>
         </p:nvPicPr>
         <p:blipFill>
-          <a:blip r:embed="rId1"/>
-          <a:srcRect l="0" r="0" t="0" b="0"/>
+          <a:blip r:embed="rId3"/>
+          <a:srcRect/>
           <a:stretch/>
         </p:blipFill>
         <p:spPr>
@@ -2591,9 +2330,7 @@
             <a:ext cx="2560320" cy="256032"/>
           </a:xfrm>
           <a:prstGeom prst="rect">
-            <a:avLst>
-              <a:gd name="adj" fmla="val 21429"/>
-            </a:avLst>
+            <a:avLst/>
           </a:prstGeom>
           <a:solidFill>
             <a:srgbClr val="241D09"/>
@@ -2627,7 +2364,7 @@
           <a:bodyPr wrap="square" lIns="0" tIns="0" rIns="0" bIns="0" rtlCol="0" anchor="ctr"/>
           <a:lstStyle/>
           <a:p>
-            <a:pPr indent="0" marL="0">
+            <a:pPr marL="0" indent="0">
               <a:buNone/>
             </a:pPr>
             <a:r>
@@ -2666,7 +2403,7 @@
           <a:bodyPr wrap="square" lIns="0" tIns="0" rIns="0" bIns="0" rtlCol="0" anchor="ctr"/>
           <a:lstStyle/>
           <a:p>
-            <a:pPr indent="0" marL="0">
+            <a:pPr marL="0" indent="0">
               <a:lnSpc>
                 <a:spcPts val="1300"/>
               </a:lnSpc>
@@ -2686,7 +2423,7 @@
             <a:endParaRPr lang="en-US" sz="850" dirty="0"/>
           </a:p>
           <a:p>
-            <a:pPr indent="0" marL="0">
+            <a:pPr marL="0" indent="0">
               <a:lnSpc>
                 <a:spcPts val="1300"/>
               </a:lnSpc>
@@ -2706,7 +2443,7 @@
             <a:endParaRPr lang="en-US" sz="850" dirty="0"/>
           </a:p>
           <a:p>
-            <a:pPr indent="0" marL="0">
+            <a:pPr marL="0" indent="0">
               <a:lnSpc>
                 <a:spcPts val="1300"/>
               </a:lnSpc>
@@ -2726,7 +2463,7 @@
             <a:endParaRPr lang="en-US" sz="850" dirty="0"/>
           </a:p>
           <a:p>
-            <a:pPr indent="0" marL="0">
+            <a:pPr marL="0" indent="0">
               <a:lnSpc>
                 <a:spcPts val="1300"/>
               </a:lnSpc>
@@ -2784,9 +2521,7 @@
             <a:ext cx="3941064" cy="256032"/>
           </a:xfrm>
           <a:prstGeom prst="rect">
-            <a:avLst>
-              <a:gd name="adj" fmla="val 21429"/>
-            </a:avLst>
+            <a:avLst/>
           </a:prstGeom>
           <a:solidFill>
             <a:srgbClr val="241D09"/>
@@ -2820,7 +2555,7 @@
           <a:bodyPr wrap="square" lIns="0" tIns="0" rIns="0" bIns="0" rtlCol="0" anchor="ctr"/>
           <a:lstStyle/>
           <a:p>
-            <a:pPr indent="0" marL="0">
+            <a:pPr marL="0" indent="0">
               <a:buNone/>
             </a:pPr>
             <a:r>
@@ -2859,7 +2594,7 @@
           <a:bodyPr wrap="square" lIns="0" tIns="0" rIns="0" bIns="0" rtlCol="0" anchor="ctr"/>
           <a:lstStyle/>
           <a:p>
-            <a:pPr indent="0" marL="0">
+            <a:pPr marL="0" indent="0">
               <a:buNone/>
             </a:pPr>
             <a:r>
@@ -2889,9 +2624,7 @@
             <a:ext cx="4846320" cy="1600200"/>
           </a:xfrm>
           <a:prstGeom prst="rect">
-            <a:avLst>
-              <a:gd name="adj" fmla="val 2286"/>
-            </a:avLst>
+            <a:avLst/>
           </a:prstGeom>
           <a:solidFill>
             <a:srgbClr val="13131D"/>
@@ -2925,7 +2658,7 @@
           <a:bodyPr wrap="square" lIns="0" tIns="0" rIns="0" bIns="0" rtlCol="0" anchor="ctr"/>
           <a:lstStyle/>
           <a:p>
-            <a:pPr indent="0" marL="0">
+            <a:pPr marL="0" indent="0">
               <a:buNone/>
             </a:pPr>
             <a:r>
@@ -2964,7 +2697,7 @@
           <a:bodyPr wrap="square" lIns="0" tIns="0" rIns="0" bIns="0" rtlCol="0" anchor="ctr"/>
           <a:lstStyle/>
           <a:p>
-            <a:pPr indent="0" marL="0">
+            <a:pPr marL="0" indent="0">
               <a:lnSpc>
                 <a:spcPts val="1300"/>
               </a:lnSpc>
@@ -2997,9 +2730,7 @@
             <a:ext cx="4846320" cy="1600200"/>
           </a:xfrm>
           <a:prstGeom prst="rect">
-            <a:avLst>
-              <a:gd name="adj" fmla="val 2286"/>
-            </a:avLst>
+            <a:avLst/>
           </a:prstGeom>
           <a:solidFill>
             <a:srgbClr val="13131D"/>
@@ -3033,7 +2764,7 @@
           <a:bodyPr wrap="square" lIns="0" tIns="0" rIns="0" bIns="0" rtlCol="0" anchor="ctr"/>
           <a:lstStyle/>
           <a:p>
-            <a:pPr indent="0" marL="0">
+            <a:pPr marL="0" indent="0">
               <a:buNone/>
             </a:pPr>
             <a:r>
@@ -3072,7 +2803,7 @@
           <a:bodyPr wrap="square" lIns="0" tIns="0" rIns="0" bIns="0" rtlCol="0" anchor="ctr"/>
           <a:lstStyle/>
           <a:p>
-            <a:pPr indent="0" marL="0">
+            <a:pPr marL="0" indent="0">
               <a:lnSpc>
                 <a:spcPts val="1300"/>
               </a:lnSpc>
@@ -3105,9 +2836,7 @@
             <a:ext cx="4846320" cy="1600200"/>
           </a:xfrm>
           <a:prstGeom prst="rect">
-            <a:avLst>
-              <a:gd name="adj" fmla="val 2286"/>
-            </a:avLst>
+            <a:avLst/>
           </a:prstGeom>
           <a:solidFill>
             <a:srgbClr val="13131D"/>
@@ -3141,7 +2870,7 @@
           <a:bodyPr wrap="square" lIns="0" tIns="0" rIns="0" bIns="0" rtlCol="0" anchor="ctr"/>
           <a:lstStyle/>
           <a:p>
-            <a:pPr indent="0" marL="0">
+            <a:pPr marL="0" indent="0">
               <a:buNone/>
             </a:pPr>
             <a:r>
@@ -3180,7 +2909,7 @@
           <a:bodyPr wrap="square" lIns="0" tIns="0" rIns="0" bIns="0" rtlCol="0" anchor="ctr"/>
           <a:lstStyle/>
           <a:p>
-            <a:pPr indent="0" marL="0">
+            <a:pPr marL="0" indent="0">
               <a:lnSpc>
                 <a:spcPts val="1300"/>
               </a:lnSpc>
@@ -3213,9 +2942,7 @@
             <a:ext cx="6062472" cy="5120640"/>
           </a:xfrm>
           <a:prstGeom prst="rect">
-            <a:avLst>
-              <a:gd name="adj" fmla="val 714"/>
-            </a:avLst>
+            <a:avLst/>
           </a:prstGeom>
           <a:solidFill>
             <a:srgbClr val="13131D"/>
@@ -3240,9 +2967,7 @@
             <a:ext cx="2975458" cy="256032"/>
           </a:xfrm>
           <a:prstGeom prst="rect">
-            <a:avLst>
-              <a:gd name="adj" fmla="val 21429"/>
-            </a:avLst>
+            <a:avLst/>
           </a:prstGeom>
           <a:solidFill>
             <a:srgbClr val="241D09"/>
@@ -3276,7 +3001,7 @@
           <a:bodyPr wrap="square" lIns="0" tIns="0" rIns="0" bIns="0" rtlCol="0" anchor="ctr"/>
           <a:lstStyle/>
           <a:p>
-            <a:pPr indent="0" marL="0">
+            <a:pPr marL="0" indent="0">
               <a:buNone/>
             </a:pPr>
             <a:r>
@@ -3315,7 +3040,7 @@
           <a:bodyPr wrap="square" lIns="0" tIns="0" rIns="0" bIns="0" rtlCol="0" anchor="ctr"/>
           <a:lstStyle/>
           <a:p>
-            <a:pPr indent="0" marL="0">
+            <a:pPr marL="0" indent="0">
               <a:buNone/>
             </a:pPr>
             <a:r>
@@ -3354,7 +3079,7 @@
           <a:bodyPr wrap="square" lIns="0" tIns="0" rIns="0" bIns="0" rtlCol="0" anchor="ctr"/>
           <a:lstStyle/>
           <a:p>
-            <a:pPr indent="0" marL="0">
+            <a:pPr marL="0" indent="0">
               <a:buNone/>
             </a:pPr>
             <a:r>
@@ -3393,7 +3118,7 @@
           <a:bodyPr wrap="square" lIns="0" tIns="0" rIns="0" bIns="0" rtlCol="0" anchor="ctr"/>
           <a:lstStyle/>
           <a:p>
-            <a:pPr indent="0" marL="0">
+            <a:pPr marL="0" indent="0">
               <a:lnSpc>
                 <a:spcPts val="1100"/>
               </a:lnSpc>
@@ -3435,7 +3160,7 @@
           <a:bodyPr wrap="square" lIns="0" tIns="0" rIns="0" bIns="0" rtlCol="0" anchor="ctr"/>
           <a:lstStyle/>
           <a:p>
-            <a:pPr indent="0" marL="0">
+            <a:pPr marL="0" indent="0">
               <a:buNone/>
             </a:pPr>
             <a:r>
@@ -3474,7 +3199,7 @@
           <a:bodyPr wrap="square" lIns="0" tIns="0" rIns="0" bIns="0" rtlCol="0" anchor="ctr"/>
           <a:lstStyle/>
           <a:p>
-            <a:pPr indent="0" marL="0">
+            <a:pPr marL="0" indent="0">
               <a:buNone/>
             </a:pPr>
             <a:r>
@@ -3513,7 +3238,7 @@
           <a:bodyPr wrap="square" lIns="0" tIns="0" rIns="0" bIns="0" rtlCol="0" anchor="ctr"/>
           <a:lstStyle/>
           <a:p>
-            <a:pPr indent="0" marL="0">
+            <a:pPr marL="0" indent="0">
               <a:lnSpc>
                 <a:spcPts val="1100"/>
               </a:lnSpc>
@@ -3555,7 +3280,7 @@
           <a:bodyPr wrap="square" lIns="0" tIns="0" rIns="0" bIns="0" rtlCol="0" anchor="ctr"/>
           <a:lstStyle/>
           <a:p>
-            <a:pPr indent="0" marL="0">
+            <a:pPr marL="0" indent="0">
               <a:buNone/>
             </a:pPr>
             <a:r>
@@ -3594,7 +3319,7 @@
           <a:bodyPr wrap="square" lIns="0" tIns="0" rIns="0" bIns="0" rtlCol="0" anchor="ctr"/>
           <a:lstStyle/>
           <a:p>
-            <a:pPr indent="0" marL="0">
+            <a:pPr marL="0" indent="0">
               <a:buNone/>
             </a:pPr>
             <a:r>
@@ -3633,7 +3358,7 @@
           <a:bodyPr wrap="square" lIns="0" tIns="0" rIns="0" bIns="0" rtlCol="0" anchor="ctr"/>
           <a:lstStyle/>
           <a:p>
-            <a:pPr indent="0" marL="0">
+            <a:pPr marL="0" indent="0">
               <a:lnSpc>
                 <a:spcPts val="1100"/>
               </a:lnSpc>
@@ -3691,9 +3416,7 @@
             <a:ext cx="3780130" cy="256032"/>
           </a:xfrm>
           <a:prstGeom prst="rect">
-            <a:avLst>
-              <a:gd name="adj" fmla="val 21429"/>
-            </a:avLst>
+            <a:avLst/>
           </a:prstGeom>
           <a:solidFill>
             <a:srgbClr val="241D09"/>
@@ -3727,7 +3450,7 @@
           <a:bodyPr wrap="square" lIns="0" tIns="0" rIns="0" bIns="0" rtlCol="0" anchor="ctr"/>
           <a:lstStyle/>
           <a:p>
-            <a:pPr indent="0" marL="0">
+            <a:pPr marL="0" indent="0">
               <a:buNone/>
             </a:pPr>
             <a:r>
@@ -3766,7 +3489,7 @@
           <a:bodyPr wrap="square" lIns="0" tIns="0" rIns="0" bIns="0" rtlCol="0" anchor="ctr"/>
           <a:lstStyle/>
           <a:p>
-            <a:pPr indent="0" marL="0">
+            <a:pPr marL="0" indent="0">
               <a:buNone/>
             </a:pPr>
             <a:r>
@@ -3786,7 +3509,7 @@
       </p:sp>
       <p:graphicFrame>
         <p:nvGraphicFramePr>
-          <p:cNvPr id="4" name="Table 0"/>
+          <p:cNvPr id="5" name="Table 0"/>
           <p:cNvGraphicFramePr>
             <a:graphicFrameLocks noGrp="1"/>
           </p:cNvGraphicFramePr>
@@ -3800,17 +3523,41 @@
         </p:nvGraphicFramePr>
         <p:xfrm>
           <a:off x="548640" y="1188720"/>
-          <a:ext cx="11094415" cy="3017520"/>
+          <a:ext cx="11094416" cy="3017520"/>
         </p:xfrm>
         <a:graphic>
           <a:graphicData uri="http://schemas.openxmlformats.org/drawingml/2006/table">
             <a:tbl>
               <a:tblPr/>
               <a:tblGrid>
-                <a:gridCol w="2773604"/>
-                <a:gridCol w="2773604"/>
-                <a:gridCol w="2773604"/>
-                <a:gridCol w="2773604"/>
+                <a:gridCol w="2773604">
+                  <a:extLst>
+                    <a:ext uri="{9D8B030D-6E8A-4147-A177-3AD203B41FA5}">
+                      <a16:colId xmlns:a16="http://schemas.microsoft.com/office/drawing/2014/main" val="20000"/>
+                    </a:ext>
+                  </a:extLst>
+                </a:gridCol>
+                <a:gridCol w="2773604">
+                  <a:extLst>
+                    <a:ext uri="{9D8B030D-6E8A-4147-A177-3AD203B41FA5}">
+                      <a16:colId xmlns:a16="http://schemas.microsoft.com/office/drawing/2014/main" val="20001"/>
+                    </a:ext>
+                  </a:extLst>
+                </a:gridCol>
+                <a:gridCol w="2773604">
+                  <a:extLst>
+                    <a:ext uri="{9D8B030D-6E8A-4147-A177-3AD203B41FA5}">
+                      <a16:colId xmlns:a16="http://schemas.microsoft.com/office/drawing/2014/main" val="20002"/>
+                    </a:ext>
+                  </a:extLst>
+                </a:gridCol>
+                <a:gridCol w="2773604">
+                  <a:extLst>
+                    <a:ext uri="{9D8B030D-6E8A-4147-A177-3AD203B41FA5}">
+                      <a16:colId xmlns:a16="http://schemas.microsoft.com/office/drawing/2014/main" val="20003"/>
+                    </a:ext>
+                  </a:extLst>
+                </a:gridCol>
               </a:tblGrid>
               <a:tr h="502920">
                 <a:tc>
@@ -3818,7 +3565,7 @@
                     <a:bodyPr/>
                     <a:lstStyle/>
                     <a:p>
-                      <a:pPr algn="l" indent="0" marL="0">
+                      <a:pPr marL="0" indent="0" algn="l">
                         <a:buNone/>
                       </a:pPr>
                       <a:r>
@@ -3832,7 +3579,7 @@
                       <a:endParaRPr lang="en-US" sz="900" dirty="0"/>
                     </a:p>
                   </a:txBody>
-                  <a:tcPr marL="91440" marR="91440" marT="45720" marB="45720" anchor="ctr">
+                  <a:tcPr anchor="ctr">
                     <a:lnL w="12700" cap="flat" cmpd="sng" algn="ctr">
                       <a:solidFill>
                         <a:srgbClr val="242436"/>
@@ -3879,7 +3626,7 @@
                     <a:bodyPr/>
                     <a:lstStyle/>
                     <a:p>
-                      <a:pPr algn="l" indent="0" marL="0">
+                      <a:pPr marL="0" indent="0" algn="l">
                         <a:buNone/>
                       </a:pPr>
                       <a:r>
@@ -3893,7 +3640,7 @@
                       <a:endParaRPr lang="en-US" sz="900" dirty="0"/>
                     </a:p>
                   </a:txBody>
-                  <a:tcPr marL="91440" marR="91440" marT="45720" marB="45720" anchor="ctr">
+                  <a:tcPr anchor="ctr">
                     <a:lnL w="12700" cap="flat" cmpd="sng" algn="ctr">
                       <a:solidFill>
                         <a:srgbClr val="242436"/>
@@ -3940,7 +3687,7 @@
                     <a:bodyPr/>
                     <a:lstStyle/>
                     <a:p>
-                      <a:pPr algn="l" indent="0" marL="0">
+                      <a:pPr marL="0" indent="0" algn="l">
                         <a:buNone/>
                       </a:pPr>
                       <a:r>
@@ -3954,7 +3701,7 @@
                       <a:endParaRPr lang="en-US" sz="900" dirty="0"/>
                     </a:p>
                   </a:txBody>
-                  <a:tcPr marL="91440" marR="91440" marT="45720" marB="45720" anchor="ctr">
+                  <a:tcPr anchor="ctr">
                     <a:lnL w="12700" cap="flat" cmpd="sng" algn="ctr">
                       <a:solidFill>
                         <a:srgbClr val="242436"/>
@@ -4001,7 +3748,7 @@
                     <a:bodyPr/>
                     <a:lstStyle/>
                     <a:p>
-                      <a:pPr algn="l" indent="0" marL="0">
+                      <a:pPr marL="0" indent="0" algn="l">
                         <a:buNone/>
                       </a:pPr>
                       <a:r>
@@ -4015,7 +3762,7 @@
                       <a:endParaRPr lang="en-US" sz="900" dirty="0"/>
                     </a:p>
                   </a:txBody>
-                  <a:tcPr marL="91440" marR="91440" marT="45720" marB="45720" anchor="ctr">
+                  <a:tcPr anchor="ctr">
                     <a:lnL w="12700" cap="flat" cmpd="sng" algn="ctr">
                       <a:solidFill>
                         <a:srgbClr val="242436"/>
@@ -4057,6 +3804,11 @@
                     </a:solidFill>
                   </a:tcPr>
                 </a:tc>
+                <a:extLst>
+                  <a:ext uri="{0D108BD9-81ED-4DB2-BD59-A6C34878D82A}">
+                    <a16:rowId xmlns:a16="http://schemas.microsoft.com/office/drawing/2014/main" val="10000"/>
+                  </a:ext>
+                </a:extLst>
               </a:tr>
               <a:tr h="502920">
                 <a:tc>
@@ -4064,7 +3816,7 @@
                     <a:bodyPr/>
                     <a:lstStyle/>
                     <a:p>
-                      <a:pPr algn="l" indent="0" marL="0">
+                      <a:pPr marL="0" indent="0" algn="l">
                         <a:buNone/>
                       </a:pPr>
                       <a:r>
@@ -4078,7 +3830,7 @@
                       <a:endParaRPr lang="en-US" sz="850" dirty="0"/>
                     </a:p>
                   </a:txBody>
-                  <a:tcPr marL="91440" marR="91440" marT="45720" marB="45720" anchor="ctr">
+                  <a:tcPr anchor="ctr">
                     <a:lnL w="12700" cap="flat" cmpd="sng" algn="ctr">
                       <a:solidFill>
                         <a:srgbClr val="242436"/>
@@ -4122,7 +3874,7 @@
                     <a:bodyPr/>
                     <a:lstStyle/>
                     <a:p>
-                      <a:pPr algn="l" indent="0" marL="0">
+                      <a:pPr marL="0" indent="0" algn="l">
                         <a:buNone/>
                       </a:pPr>
                       <a:r>
@@ -4136,7 +3888,7 @@
                       <a:endParaRPr lang="en-US" sz="850" dirty="0"/>
                     </a:p>
                   </a:txBody>
-                  <a:tcPr marL="91440" marR="91440" marT="45720" marB="45720" anchor="ctr">
+                  <a:tcPr anchor="ctr">
                     <a:lnL w="12700" cap="flat" cmpd="sng" algn="ctr">
                       <a:solidFill>
                         <a:srgbClr val="242436"/>
@@ -4180,7 +3932,7 @@
                     <a:bodyPr/>
                     <a:lstStyle/>
                     <a:p>
-                      <a:pPr algn="l" indent="0" marL="0">
+                      <a:pPr marL="0" indent="0" algn="l">
                         <a:buNone/>
                       </a:pPr>
                       <a:r>
@@ -4194,7 +3946,7 @@
                       <a:endParaRPr lang="en-US" sz="850" dirty="0"/>
                     </a:p>
                   </a:txBody>
-                  <a:tcPr marL="91440" marR="91440" marT="45720" marB="45720" anchor="ctr">
+                  <a:tcPr anchor="ctr">
                     <a:lnL w="12700" cap="flat" cmpd="sng" algn="ctr">
                       <a:solidFill>
                         <a:srgbClr val="242436"/>
@@ -4238,7 +3990,7 @@
                     <a:bodyPr/>
                     <a:lstStyle/>
                     <a:p>
-                      <a:pPr algn="l" indent="0" marL="0">
+                      <a:pPr marL="0" indent="0" algn="l">
                         <a:buNone/>
                       </a:pPr>
                       <a:r>
@@ -4252,7 +4004,7 @@
                       <a:endParaRPr lang="en-US" sz="850" dirty="0"/>
                     </a:p>
                   </a:txBody>
-                  <a:tcPr marL="91440" marR="91440" marT="45720" marB="45720" anchor="ctr">
+                  <a:tcPr anchor="ctr">
                     <a:lnL w="12700" cap="flat" cmpd="sng" algn="ctr">
                       <a:solidFill>
                         <a:srgbClr val="242436"/>
@@ -4291,6 +4043,11 @@
                     </a:lnB>
                   </a:tcPr>
                 </a:tc>
+                <a:extLst>
+                  <a:ext uri="{0D108BD9-81ED-4DB2-BD59-A6C34878D82A}">
+                    <a16:rowId xmlns:a16="http://schemas.microsoft.com/office/drawing/2014/main" val="10001"/>
+                  </a:ext>
+                </a:extLst>
               </a:tr>
               <a:tr h="502920">
                 <a:tc>
@@ -4298,7 +4055,7 @@
                     <a:bodyPr/>
                     <a:lstStyle/>
                     <a:p>
-                      <a:pPr algn="l" indent="0" marL="0">
+                      <a:pPr marL="0" indent="0" algn="l">
                         <a:buNone/>
                       </a:pPr>
                       <a:r>
@@ -4312,7 +4069,7 @@
                       <a:endParaRPr lang="en-US" sz="850" dirty="0"/>
                     </a:p>
                   </a:txBody>
-                  <a:tcPr marL="91440" marR="91440" marT="45720" marB="45720" anchor="ctr">
+                  <a:tcPr anchor="ctr">
                     <a:lnL w="12700" cap="flat" cmpd="sng" algn="ctr">
                       <a:solidFill>
                         <a:srgbClr val="242436"/>
@@ -4356,7 +4113,7 @@
                     <a:bodyPr/>
                     <a:lstStyle/>
                     <a:p>
-                      <a:pPr algn="l" indent="0" marL="0">
+                      <a:pPr marL="0" indent="0" algn="l">
                         <a:buNone/>
                       </a:pPr>
                       <a:r>
@@ -4370,7 +4127,7 @@
                       <a:endParaRPr lang="en-US" sz="850" dirty="0"/>
                     </a:p>
                   </a:txBody>
-                  <a:tcPr marL="91440" marR="91440" marT="45720" marB="45720" anchor="ctr">
+                  <a:tcPr anchor="ctr">
                     <a:lnL w="12700" cap="flat" cmpd="sng" algn="ctr">
                       <a:solidFill>
                         <a:srgbClr val="242436"/>
@@ -4414,7 +4171,7 @@
                     <a:bodyPr/>
                     <a:lstStyle/>
                     <a:p>
-                      <a:pPr algn="l" indent="0" marL="0">
+                      <a:pPr marL="0" indent="0" algn="l">
                         <a:buNone/>
                       </a:pPr>
                       <a:r>
@@ -4428,7 +4185,7 @@
                       <a:endParaRPr lang="en-US" sz="850" dirty="0"/>
                     </a:p>
                   </a:txBody>
-                  <a:tcPr marL="91440" marR="91440" marT="45720" marB="45720" anchor="ctr">
+                  <a:tcPr anchor="ctr">
                     <a:lnL w="12700" cap="flat" cmpd="sng" algn="ctr">
                       <a:solidFill>
                         <a:srgbClr val="242436"/>
@@ -4472,7 +4229,7 @@
                     <a:bodyPr/>
                     <a:lstStyle/>
                     <a:p>
-                      <a:pPr algn="l" indent="0" marL="0">
+                      <a:pPr marL="0" indent="0" algn="l">
                         <a:buNone/>
                       </a:pPr>
                       <a:r>
@@ -4486,7 +4243,7 @@
                       <a:endParaRPr lang="en-US" sz="850" dirty="0"/>
                     </a:p>
                   </a:txBody>
-                  <a:tcPr marL="91440" marR="91440" marT="45720" marB="45720" anchor="ctr">
+                  <a:tcPr anchor="ctr">
                     <a:lnL w="12700" cap="flat" cmpd="sng" algn="ctr">
                       <a:solidFill>
                         <a:srgbClr val="242436"/>
@@ -4525,6 +4282,11 @@
                     </a:lnB>
                   </a:tcPr>
                 </a:tc>
+                <a:extLst>
+                  <a:ext uri="{0D108BD9-81ED-4DB2-BD59-A6C34878D82A}">
+                    <a16:rowId xmlns:a16="http://schemas.microsoft.com/office/drawing/2014/main" val="10002"/>
+                  </a:ext>
+                </a:extLst>
               </a:tr>
               <a:tr h="502920">
                 <a:tc>
@@ -4532,7 +4294,7 @@
                     <a:bodyPr/>
                     <a:lstStyle/>
                     <a:p>
-                      <a:pPr algn="l" indent="0" marL="0">
+                      <a:pPr marL="0" indent="0" algn="l">
                         <a:buNone/>
                       </a:pPr>
                       <a:r>
@@ -4546,7 +4308,7 @@
                       <a:endParaRPr lang="en-US" sz="850" dirty="0"/>
                     </a:p>
                   </a:txBody>
-                  <a:tcPr marL="91440" marR="91440" marT="45720" marB="45720" anchor="ctr">
+                  <a:tcPr anchor="ctr">
                     <a:lnL w="12700" cap="flat" cmpd="sng" algn="ctr">
                       <a:solidFill>
                         <a:srgbClr val="242436"/>
@@ -4590,7 +4352,7 @@
                     <a:bodyPr/>
                     <a:lstStyle/>
                     <a:p>
-                      <a:pPr algn="l" indent="0" marL="0">
+                      <a:pPr marL="0" indent="0" algn="l">
                         <a:buNone/>
                       </a:pPr>
                       <a:r>
@@ -4604,7 +4366,7 @@
                       <a:endParaRPr lang="en-US" sz="850" dirty="0"/>
                     </a:p>
                   </a:txBody>
-                  <a:tcPr marL="91440" marR="91440" marT="45720" marB="45720" anchor="ctr">
+                  <a:tcPr anchor="ctr">
                     <a:lnL w="12700" cap="flat" cmpd="sng" algn="ctr">
                       <a:solidFill>
                         <a:srgbClr val="242436"/>
@@ -4648,7 +4410,7 @@
                     <a:bodyPr/>
                     <a:lstStyle/>
                     <a:p>
-                      <a:pPr algn="l" indent="0" marL="0">
+                      <a:pPr marL="0" indent="0" algn="l">
                         <a:buNone/>
                       </a:pPr>
                       <a:r>
@@ -4662,7 +4424,7 @@
                       <a:endParaRPr lang="en-US" sz="850" dirty="0"/>
                     </a:p>
                   </a:txBody>
-                  <a:tcPr marL="91440" marR="91440" marT="45720" marB="45720" anchor="ctr">
+                  <a:tcPr anchor="ctr">
                     <a:lnL w="12700" cap="flat" cmpd="sng" algn="ctr">
                       <a:solidFill>
                         <a:srgbClr val="242436"/>
@@ -4706,7 +4468,7 @@
                     <a:bodyPr/>
                     <a:lstStyle/>
                     <a:p>
-                      <a:pPr algn="l" indent="0" marL="0">
+                      <a:pPr marL="0" indent="0" algn="l">
                         <a:buNone/>
                       </a:pPr>
                       <a:r>
@@ -4720,7 +4482,7 @@
                       <a:endParaRPr lang="en-US" sz="850" dirty="0"/>
                     </a:p>
                   </a:txBody>
-                  <a:tcPr marL="91440" marR="91440" marT="45720" marB="45720" anchor="ctr">
+                  <a:tcPr anchor="ctr">
                     <a:lnL w="12700" cap="flat" cmpd="sng" algn="ctr">
                       <a:solidFill>
                         <a:srgbClr val="242436"/>
@@ -4759,6 +4521,11 @@
                     </a:lnB>
                   </a:tcPr>
                 </a:tc>
+                <a:extLst>
+                  <a:ext uri="{0D108BD9-81ED-4DB2-BD59-A6C34878D82A}">
+                    <a16:rowId xmlns:a16="http://schemas.microsoft.com/office/drawing/2014/main" val="10003"/>
+                  </a:ext>
+                </a:extLst>
               </a:tr>
               <a:tr h="502920">
                 <a:tc>
@@ -4766,7 +4533,7 @@
                     <a:bodyPr/>
                     <a:lstStyle/>
                     <a:p>
-                      <a:pPr algn="l" indent="0" marL="0">
+                      <a:pPr marL="0" indent="0" algn="l">
                         <a:buNone/>
                       </a:pPr>
                       <a:r>
@@ -4780,7 +4547,7 @@
                       <a:endParaRPr lang="en-US" sz="850" dirty="0"/>
                     </a:p>
                   </a:txBody>
-                  <a:tcPr marL="91440" marR="91440" marT="45720" marB="45720" anchor="ctr">
+                  <a:tcPr anchor="ctr">
                     <a:lnL w="12700" cap="flat" cmpd="sng" algn="ctr">
                       <a:solidFill>
                         <a:srgbClr val="242436"/>
@@ -4824,7 +4591,7 @@
                     <a:bodyPr/>
                     <a:lstStyle/>
                     <a:p>
-                      <a:pPr algn="l" indent="0" marL="0">
+                      <a:pPr marL="0" indent="0" algn="l">
                         <a:buNone/>
                       </a:pPr>
                       <a:r>
@@ -4838,7 +4605,7 @@
                       <a:endParaRPr lang="en-US" sz="850" dirty="0"/>
                     </a:p>
                   </a:txBody>
-                  <a:tcPr marL="91440" marR="91440" marT="45720" marB="45720" anchor="ctr">
+                  <a:tcPr anchor="ctr">
                     <a:lnL w="12700" cap="flat" cmpd="sng" algn="ctr">
                       <a:solidFill>
                         <a:srgbClr val="242436"/>
@@ -4882,7 +4649,7 @@
                     <a:bodyPr/>
                     <a:lstStyle/>
                     <a:p>
-                      <a:pPr algn="l" indent="0" marL="0">
+                      <a:pPr marL="0" indent="0" algn="l">
                         <a:buNone/>
                       </a:pPr>
                       <a:r>
@@ -4896,7 +4663,7 @@
                       <a:endParaRPr lang="en-US" sz="850" dirty="0"/>
                     </a:p>
                   </a:txBody>
-                  <a:tcPr marL="91440" marR="91440" marT="45720" marB="45720" anchor="ctr">
+                  <a:tcPr anchor="ctr">
                     <a:lnL w="12700" cap="flat" cmpd="sng" algn="ctr">
                       <a:solidFill>
                         <a:srgbClr val="242436"/>
@@ -4940,7 +4707,7 @@
                     <a:bodyPr/>
                     <a:lstStyle/>
                     <a:p>
-                      <a:pPr algn="l" indent="0" marL="0">
+                      <a:pPr marL="0" indent="0" algn="l">
                         <a:buNone/>
                       </a:pPr>
                       <a:r>
@@ -4954,7 +4721,7 @@
                       <a:endParaRPr lang="en-US" sz="850" dirty="0"/>
                     </a:p>
                   </a:txBody>
-                  <a:tcPr marL="91440" marR="91440" marT="45720" marB="45720" anchor="ctr">
+                  <a:tcPr anchor="ctr">
                     <a:lnL w="12700" cap="flat" cmpd="sng" algn="ctr">
                       <a:solidFill>
                         <a:srgbClr val="242436"/>
@@ -4993,6 +4760,11 @@
                     </a:lnB>
                   </a:tcPr>
                 </a:tc>
+                <a:extLst>
+                  <a:ext uri="{0D108BD9-81ED-4DB2-BD59-A6C34878D82A}">
+                    <a16:rowId xmlns:a16="http://schemas.microsoft.com/office/drawing/2014/main" val="10004"/>
+                  </a:ext>
+                </a:extLst>
               </a:tr>
               <a:tr h="502920">
                 <a:tc>
@@ -5000,7 +4772,7 @@
                     <a:bodyPr/>
                     <a:lstStyle/>
                     <a:p>
-                      <a:pPr algn="l" indent="0" marL="0">
+                      <a:pPr marL="0" indent="0" algn="l">
                         <a:buNone/>
                       </a:pPr>
                       <a:r>
@@ -5014,7 +4786,7 @@
                       <a:endParaRPr lang="en-US" sz="850" dirty="0"/>
                     </a:p>
                   </a:txBody>
-                  <a:tcPr marL="91440" marR="91440" marT="45720" marB="45720" anchor="ctr">
+                  <a:tcPr anchor="ctr">
                     <a:lnL w="12700" cap="flat" cmpd="sng" algn="ctr">
                       <a:solidFill>
                         <a:srgbClr val="242436"/>
@@ -5058,7 +4830,7 @@
                     <a:bodyPr/>
                     <a:lstStyle/>
                     <a:p>
-                      <a:pPr algn="l" indent="0" marL="0">
+                      <a:pPr marL="0" indent="0" algn="l">
                         <a:buNone/>
                       </a:pPr>
                       <a:r>
@@ -5072,7 +4844,7 @@
                       <a:endParaRPr lang="en-US" sz="850" dirty="0"/>
                     </a:p>
                   </a:txBody>
-                  <a:tcPr marL="91440" marR="91440" marT="45720" marB="45720" anchor="ctr">
+                  <a:tcPr anchor="ctr">
                     <a:lnL w="12700" cap="flat" cmpd="sng" algn="ctr">
                       <a:solidFill>
                         <a:srgbClr val="242436"/>
@@ -5116,7 +4888,7 @@
                     <a:bodyPr/>
                     <a:lstStyle/>
                     <a:p>
-                      <a:pPr algn="l" indent="0" marL="0">
+                      <a:pPr marL="0" indent="0" algn="l">
                         <a:buNone/>
                       </a:pPr>
                       <a:r>
@@ -5130,7 +4902,7 @@
                       <a:endParaRPr lang="en-US" sz="850" dirty="0"/>
                     </a:p>
                   </a:txBody>
-                  <a:tcPr marL="91440" marR="91440" marT="45720" marB="45720" anchor="ctr">
+                  <a:tcPr anchor="ctr">
                     <a:lnL w="12700" cap="flat" cmpd="sng" algn="ctr">
                       <a:solidFill>
                         <a:srgbClr val="242436"/>
@@ -5174,7 +4946,7 @@
                     <a:bodyPr/>
                     <a:lstStyle/>
                     <a:p>
-                      <a:pPr algn="l" indent="0" marL="0">
+                      <a:pPr marL="0" indent="0" algn="l">
                         <a:buNone/>
                       </a:pPr>
                       <a:r>
@@ -5188,7 +4960,7 @@
                       <a:endParaRPr lang="en-US" sz="850" dirty="0"/>
                     </a:p>
                   </a:txBody>
-                  <a:tcPr marL="91440" marR="91440" marT="45720" marB="45720" anchor="ctr">
+                  <a:tcPr anchor="ctr">
                     <a:lnL w="12700" cap="flat" cmpd="sng" algn="ctr">
                       <a:solidFill>
                         <a:srgbClr val="242436"/>
@@ -5227,6 +4999,11 @@
                     </a:lnB>
                   </a:tcPr>
                 </a:tc>
+                <a:extLst>
+                  <a:ext uri="{0D108BD9-81ED-4DB2-BD59-A6C34878D82A}">
+                    <a16:rowId xmlns:a16="http://schemas.microsoft.com/office/drawing/2014/main" val="10005"/>
+                  </a:ext>
+                </a:extLst>
               </a:tr>
             </a:tbl>
           </a:graphicData>
@@ -5244,9 +5021,7 @@
             <a:ext cx="11094415" cy="1920240"/>
           </a:xfrm>
           <a:prstGeom prst="rect">
-            <a:avLst>
-              <a:gd name="adj" fmla="val 1905"/>
-            </a:avLst>
+            <a:avLst/>
           </a:prstGeom>
           <a:solidFill>
             <a:srgbClr val="101624"/>
@@ -5271,9 +5046,7 @@
             <a:ext cx="3941064" cy="256032"/>
           </a:xfrm>
           <a:prstGeom prst="rect">
-            <a:avLst>
-              <a:gd name="adj" fmla="val 21429"/>
-            </a:avLst>
+            <a:avLst/>
           </a:prstGeom>
           <a:solidFill>
             <a:srgbClr val="241D09"/>
@@ -5307,7 +5080,7 @@
           <a:bodyPr wrap="square" lIns="0" tIns="0" rIns="0" bIns="0" rtlCol="0" anchor="ctr"/>
           <a:lstStyle/>
           <a:p>
-            <a:pPr indent="0" marL="0">
+            <a:pPr marL="0" indent="0">
               <a:buNone/>
             </a:pPr>
             <a:r>
@@ -5346,7 +5119,7 @@
           <a:bodyPr wrap="square" lIns="0" tIns="0" rIns="0" bIns="0" rtlCol="0" anchor="ctr"/>
           <a:lstStyle/>
           <a:p>
-            <a:pPr indent="0" marL="0">
+            <a:pPr marL="0" indent="0">
               <a:lnSpc>
                 <a:spcPts val="1300"/>
               </a:lnSpc>
@@ -5366,7 +5139,7 @@
             <a:endParaRPr lang="en-US" sz="900" dirty="0"/>
           </a:p>
           <a:p>
-            <a:pPr indent="0" marL="0">
+            <a:pPr marL="0" indent="0">
               <a:lnSpc>
                 <a:spcPts val="1300"/>
               </a:lnSpc>
@@ -5386,7 +5159,7 @@
             <a:endParaRPr lang="en-US" sz="900" dirty="0"/>
           </a:p>
           <a:p>
-            <a:pPr indent="0" marL="0">
+            <a:pPr marL="0" indent="0">
               <a:lnSpc>
                 <a:spcPts val="1300"/>
               </a:lnSpc>
@@ -5444,9 +5217,7 @@
             <a:ext cx="3860597" cy="256032"/>
           </a:xfrm>
           <a:prstGeom prst="rect">
-            <a:avLst>
-              <a:gd name="adj" fmla="val 21429"/>
-            </a:avLst>
+            <a:avLst/>
           </a:prstGeom>
           <a:solidFill>
             <a:srgbClr val="241D09"/>
@@ -5480,7 +5251,7 @@
           <a:bodyPr wrap="square" lIns="0" tIns="0" rIns="0" bIns="0" rtlCol="0" anchor="ctr"/>
           <a:lstStyle/>
           <a:p>
-            <a:pPr indent="0" marL="0">
+            <a:pPr marL="0" indent="0">
               <a:buNone/>
             </a:pPr>
             <a:r>
@@ -5519,7 +5290,7 @@
           <a:bodyPr wrap="square" lIns="0" tIns="0" rIns="0" bIns="0" rtlCol="0" anchor="ctr"/>
           <a:lstStyle/>
           <a:p>
-            <a:pPr indent="0" marL="0">
+            <a:pPr marL="0" indent="0">
               <a:buNone/>
             </a:pPr>
             <a:r>
@@ -5549,9 +5320,7 @@
             <a:ext cx="2606040" cy="2468880"/>
           </a:xfrm>
           <a:prstGeom prst="rect">
-            <a:avLst>
-              <a:gd name="adj" fmla="val 1481"/>
-            </a:avLst>
+            <a:avLst/>
           </a:prstGeom>
           <a:solidFill>
             <a:srgbClr val="13131D"/>
@@ -5585,7 +5354,7 @@
           <a:bodyPr wrap="square" lIns="0" tIns="0" rIns="0" bIns="0" rtlCol="0" anchor="ctr"/>
           <a:lstStyle/>
           <a:p>
-            <a:pPr indent="0" marL="0">
+            <a:pPr marL="0" indent="0">
               <a:buNone/>
             </a:pPr>
             <a:r>
@@ -5611,7 +5380,7 @@
         </p:nvSpPr>
         <p:spPr>
           <a:xfrm>
-            <a:off x="1280160" y="1371600"/>
+            <a:off x="1051560" y="1485900"/>
             <a:ext cx="1737360" cy="502920"/>
           </a:xfrm>
           <a:prstGeom prst="rect">
@@ -5624,7 +5393,7 @@
           <a:bodyPr wrap="square" lIns="0" tIns="0" rIns="0" bIns="0" rtlCol="0" anchor="ctr"/>
           <a:lstStyle/>
           <a:p>
-            <a:pPr indent="0" marL="0">
+            <a:pPr marL="0" indent="0">
               <a:buNone/>
             </a:pPr>
             <a:r>
@@ -5663,7 +5432,7 @@
           <a:bodyPr wrap="square" lIns="0" tIns="0" rIns="0" bIns="0" rtlCol="0" anchor="ctr"/>
           <a:lstStyle/>
           <a:p>
-            <a:pPr indent="0" marL="0">
+            <a:pPr marL="0" indent="0">
               <a:lnSpc>
                 <a:spcPts val="1100"/>
               </a:lnSpc>
@@ -5692,13 +5461,11 @@
         </p:nvSpPr>
         <p:spPr>
           <a:xfrm>
-            <a:off x="3291840" y="1188720"/>
+            <a:off x="3360420" y="1197864"/>
             <a:ext cx="2606040" cy="2468880"/>
           </a:xfrm>
           <a:prstGeom prst="rect">
-            <a:avLst>
-              <a:gd name="adj" fmla="val 1481"/>
-            </a:avLst>
+            <a:avLst/>
           </a:prstGeom>
           <a:solidFill>
             <a:srgbClr val="13131D"/>
@@ -5732,7 +5499,7 @@
           <a:bodyPr wrap="square" lIns="0" tIns="0" rIns="0" bIns="0" rtlCol="0" anchor="ctr"/>
           <a:lstStyle/>
           <a:p>
-            <a:pPr indent="0" marL="0">
+            <a:pPr marL="0" indent="0">
               <a:buNone/>
             </a:pPr>
             <a:r>
@@ -5758,7 +5525,7 @@
         </p:nvSpPr>
         <p:spPr>
           <a:xfrm>
-            <a:off x="4023360" y="1371600"/>
+            <a:off x="3794760" y="1456436"/>
             <a:ext cx="1737360" cy="502920"/>
           </a:xfrm>
           <a:prstGeom prst="rect">
@@ -5771,7 +5538,7 @@
           <a:bodyPr wrap="square" lIns="0" tIns="0" rIns="0" bIns="0" rtlCol="0" anchor="ctr"/>
           <a:lstStyle/>
           <a:p>
-            <a:pPr indent="0" marL="0">
+            <a:pPr marL="0" indent="0">
               <a:buNone/>
             </a:pPr>
             <a:r>
@@ -5810,7 +5577,7 @@
           <a:bodyPr wrap="square" lIns="0" tIns="0" rIns="0" bIns="0" rtlCol="0" anchor="ctr"/>
           <a:lstStyle/>
           <a:p>
-            <a:pPr indent="0" marL="0">
+            <a:pPr marL="0" indent="0">
               <a:lnSpc>
                 <a:spcPts val="1100"/>
               </a:lnSpc>
@@ -5843,9 +5610,7 @@
             <a:ext cx="2606040" cy="2468880"/>
           </a:xfrm>
           <a:prstGeom prst="rect">
-            <a:avLst>
-              <a:gd name="adj" fmla="val 1481"/>
-            </a:avLst>
+            <a:avLst/>
           </a:prstGeom>
           <a:solidFill>
             <a:srgbClr val="13131D"/>
@@ -5879,7 +5644,7 @@
           <a:bodyPr wrap="square" lIns="0" tIns="0" rIns="0" bIns="0" rtlCol="0" anchor="ctr"/>
           <a:lstStyle/>
           <a:p>
-            <a:pPr indent="0" marL="0">
+            <a:pPr marL="0" indent="0">
               <a:buNone/>
             </a:pPr>
             <a:r>
@@ -5905,7 +5670,7 @@
         </p:nvSpPr>
         <p:spPr>
           <a:xfrm>
-            <a:off x="1280160" y="3977640"/>
+            <a:off x="1051560" y="4000500"/>
             <a:ext cx="1737360" cy="502920"/>
           </a:xfrm>
           <a:prstGeom prst="rect">
@@ -5918,7 +5683,7 @@
           <a:bodyPr wrap="square" lIns="0" tIns="0" rIns="0" bIns="0" rtlCol="0" anchor="ctr"/>
           <a:lstStyle/>
           <a:p>
-            <a:pPr indent="0" marL="0">
+            <a:pPr marL="0" indent="0">
               <a:buNone/>
             </a:pPr>
             <a:r>
@@ -5957,7 +5722,7 @@
           <a:bodyPr wrap="square" lIns="0" tIns="0" rIns="0" bIns="0" rtlCol="0" anchor="ctr"/>
           <a:lstStyle/>
           <a:p>
-            <a:pPr indent="0" marL="0">
+            <a:pPr marL="0" indent="0">
               <a:lnSpc>
                 <a:spcPts val="1100"/>
               </a:lnSpc>
@@ -5990,9 +5755,7 @@
             <a:ext cx="2606040" cy="2468880"/>
           </a:xfrm>
           <a:prstGeom prst="rect">
-            <a:avLst>
-              <a:gd name="adj" fmla="val 1481"/>
-            </a:avLst>
+            <a:avLst/>
           </a:prstGeom>
           <a:solidFill>
             <a:srgbClr val="13131D"/>
@@ -6026,7 +5789,7 @@
           <a:bodyPr wrap="square" lIns="0" tIns="0" rIns="0" bIns="0" rtlCol="0" anchor="ctr"/>
           <a:lstStyle/>
           <a:p>
-            <a:pPr indent="0" marL="0">
+            <a:pPr marL="0" indent="0">
               <a:buNone/>
             </a:pPr>
             <a:r>
@@ -6052,7 +5815,7 @@
         </p:nvSpPr>
         <p:spPr>
           <a:xfrm>
-            <a:off x="4023360" y="3977640"/>
+            <a:off x="3794760" y="4058412"/>
             <a:ext cx="1737360" cy="502920"/>
           </a:xfrm>
           <a:prstGeom prst="rect">
@@ -6065,7 +5828,7 @@
           <a:bodyPr wrap="square" lIns="0" tIns="0" rIns="0" bIns="0" rtlCol="0" anchor="ctr"/>
           <a:lstStyle/>
           <a:p>
-            <a:pPr indent="0" marL="0">
+            <a:pPr marL="0" indent="0">
               <a:buNone/>
             </a:pPr>
             <a:r>
@@ -6104,7 +5867,7 @@
           <a:bodyPr wrap="square" lIns="0" tIns="0" rIns="0" bIns="0" rtlCol="0" anchor="ctr"/>
           <a:lstStyle/>
           <a:p>
-            <a:pPr indent="0" marL="0">
+            <a:pPr marL="0" indent="0">
               <a:lnSpc>
                 <a:spcPts val="1100"/>
               </a:lnSpc>
@@ -6137,9 +5900,7 @@
             <a:ext cx="5608015" cy="5120640"/>
           </a:xfrm>
           <a:prstGeom prst="rect">
-            <a:avLst>
-              <a:gd name="adj" fmla="val 714"/>
-            </a:avLst>
+            <a:avLst/>
           </a:prstGeom>
           <a:solidFill>
             <a:srgbClr val="13131D"/>
@@ -6154,15 +5915,15 @@
       </p:sp>
       <p:pic>
         <p:nvPicPr>
-          <p:cNvPr id="22" name="Image 0" descr="D:\hackathon_elicit_acm\assets\ingestion_terminal.png">    </p:cNvPr>
+          <p:cNvPr id="22" name="Image 0" descr="D:\hackathon_elicit_acm\assets\ingestion_terminal.png"/>
           <p:cNvPicPr>
             <a:picLocks noChangeAspect="1"/>
           </p:cNvPicPr>
           <p:nvPr/>
         </p:nvPicPr>
         <p:blipFill>
-          <a:blip r:embed="rId1"/>
-          <a:srcRect l="0" r="0" t="0" b="0"/>
+          <a:blip r:embed="rId3"/>
+          <a:srcRect/>
           <a:stretch/>
         </p:blipFill>
         <p:spPr>
@@ -6187,9 +5948,7 @@
             <a:ext cx="2894990" cy="256032"/>
           </a:xfrm>
           <a:prstGeom prst="rect">
-            <a:avLst>
-              <a:gd name="adj" fmla="val 21429"/>
-            </a:avLst>
+            <a:avLst/>
           </a:prstGeom>
           <a:solidFill>
             <a:srgbClr val="241D09"/>
@@ -6223,7 +5982,7 @@
           <a:bodyPr wrap="square" lIns="0" tIns="0" rIns="0" bIns="0" rtlCol="0" anchor="ctr"/>
           <a:lstStyle/>
           <a:p>
-            <a:pPr indent="0" marL="0">
+            <a:pPr marL="0" indent="0">
               <a:buNone/>
             </a:pPr>
             <a:r>
@@ -6262,7 +6021,7 @@
           <a:bodyPr wrap="square" lIns="0" tIns="0" rIns="0" bIns="0" rtlCol="0" anchor="ctr"/>
           <a:lstStyle/>
           <a:p>
-            <a:pPr indent="0" marL="0">
+            <a:pPr marL="0" indent="0">
               <a:lnSpc>
                 <a:spcPts val="1200"/>
               </a:lnSpc>
@@ -6282,7 +6041,7 @@
             <a:endParaRPr lang="en-US" sz="800" dirty="0"/>
           </a:p>
           <a:p>
-            <a:pPr indent="0" marL="0">
+            <a:pPr marL="0" indent="0">
               <a:lnSpc>
                 <a:spcPts val="1200"/>
               </a:lnSpc>
@@ -6302,7 +6061,7 @@
             <a:endParaRPr lang="en-US" sz="800" dirty="0"/>
           </a:p>
           <a:p>
-            <a:pPr indent="0" marL="0">
+            <a:pPr marL="0" indent="0">
               <a:lnSpc>
                 <a:spcPts val="1200"/>
               </a:lnSpc>
@@ -6360,9 +6119,7 @@
             <a:ext cx="3458261" cy="256032"/>
           </a:xfrm>
           <a:prstGeom prst="rect">
-            <a:avLst>
-              <a:gd name="adj" fmla="val 21429"/>
-            </a:avLst>
+            <a:avLst/>
           </a:prstGeom>
           <a:solidFill>
             <a:srgbClr val="241D09"/>
@@ -6396,7 +6153,7 @@
           <a:bodyPr wrap="square" lIns="0" tIns="0" rIns="0" bIns="0" rtlCol="0" anchor="ctr"/>
           <a:lstStyle/>
           <a:p>
-            <a:pPr indent="0" marL="0">
+            <a:pPr marL="0" indent="0">
               <a:buNone/>
             </a:pPr>
             <a:r>
@@ -6435,7 +6192,7 @@
           <a:bodyPr wrap="square" lIns="0" tIns="0" rIns="0" bIns="0" rtlCol="0" anchor="ctr"/>
           <a:lstStyle/>
           <a:p>
-            <a:pPr indent="0" marL="0">
+            <a:pPr marL="0" indent="0">
               <a:buNone/>
             </a:pPr>
             <a:r>
@@ -6465,9 +6222,7 @@
             <a:ext cx="2148840" cy="2011680"/>
           </a:xfrm>
           <a:prstGeom prst="rect">
-            <a:avLst>
-              <a:gd name="adj" fmla="val 1818"/>
-            </a:avLst>
+            <a:avLst/>
           </a:prstGeom>
           <a:solidFill>
             <a:srgbClr val="13131D"/>
@@ -6501,7 +6256,7 @@
           <a:bodyPr wrap="square" lIns="0" tIns="0" rIns="0" bIns="0" rtlCol="0" anchor="ctr"/>
           <a:lstStyle/>
           <a:p>
-            <a:pPr indent="0" marL="0">
+            <a:pPr marL="0" indent="0">
               <a:buNone/>
             </a:pPr>
             <a:r>
@@ -6540,7 +6295,7 @@
           <a:bodyPr wrap="square" lIns="0" tIns="0" rIns="0" bIns="0" rtlCol="0" anchor="ctr"/>
           <a:lstStyle/>
           <a:p>
-            <a:pPr indent="0" marL="0">
+            <a:pPr marL="0" indent="0">
               <a:buNone/>
             </a:pPr>
             <a:r>
@@ -6579,7 +6334,7 @@
           <a:bodyPr wrap="square" lIns="0" tIns="0" rIns="0" bIns="0" rtlCol="0" anchor="ctr"/>
           <a:lstStyle/>
           <a:p>
-            <a:pPr indent="0" marL="0">
+            <a:pPr marL="0" indent="0">
               <a:lnSpc>
                 <a:spcPts val="1100"/>
               </a:lnSpc>
@@ -6612,9 +6367,7 @@
             <a:ext cx="2148840" cy="2011680"/>
           </a:xfrm>
           <a:prstGeom prst="rect">
-            <a:avLst>
-              <a:gd name="adj" fmla="val 1818"/>
-            </a:avLst>
+            <a:avLst/>
           </a:prstGeom>
           <a:solidFill>
             <a:srgbClr val="13131D"/>
@@ -6648,7 +6401,7 @@
           <a:bodyPr wrap="square" lIns="0" tIns="0" rIns="0" bIns="0" rtlCol="0" anchor="ctr"/>
           <a:lstStyle/>
           <a:p>
-            <a:pPr indent="0" marL="0">
+            <a:pPr marL="0" indent="0">
               <a:buNone/>
             </a:pPr>
             <a:r>
@@ -6687,7 +6440,7 @@
           <a:bodyPr wrap="square" lIns="0" tIns="0" rIns="0" bIns="0" rtlCol="0" anchor="ctr"/>
           <a:lstStyle/>
           <a:p>
-            <a:pPr indent="0" marL="0">
+            <a:pPr marL="0" indent="0">
               <a:buNone/>
             </a:pPr>
             <a:r>
@@ -6726,7 +6479,7 @@
           <a:bodyPr wrap="square" lIns="0" tIns="0" rIns="0" bIns="0" rtlCol="0" anchor="ctr"/>
           <a:lstStyle/>
           <a:p>
-            <a:pPr indent="0" marL="0">
+            <a:pPr marL="0" indent="0">
               <a:lnSpc>
                 <a:spcPts val="1100"/>
               </a:lnSpc>
@@ -6759,9 +6512,7 @@
             <a:ext cx="2148840" cy="2011680"/>
           </a:xfrm>
           <a:prstGeom prst="rect">
-            <a:avLst>
-              <a:gd name="adj" fmla="val 1818"/>
-            </a:avLst>
+            <a:avLst/>
           </a:prstGeom>
           <a:solidFill>
             <a:srgbClr val="13131D"/>
@@ -6795,7 +6546,7 @@
           <a:bodyPr wrap="square" lIns="0" tIns="0" rIns="0" bIns="0" rtlCol="0" anchor="ctr"/>
           <a:lstStyle/>
           <a:p>
-            <a:pPr indent="0" marL="0">
+            <a:pPr marL="0" indent="0">
               <a:buNone/>
             </a:pPr>
             <a:r>
@@ -6834,7 +6585,7 @@
           <a:bodyPr wrap="square" lIns="0" tIns="0" rIns="0" bIns="0" rtlCol="0" anchor="ctr"/>
           <a:lstStyle/>
           <a:p>
-            <a:pPr indent="0" marL="0">
+            <a:pPr marL="0" indent="0">
               <a:buNone/>
             </a:pPr>
             <a:r>
@@ -6873,7 +6624,7 @@
           <a:bodyPr wrap="square" lIns="0" tIns="0" rIns="0" bIns="0" rtlCol="0" anchor="ctr"/>
           <a:lstStyle/>
           <a:p>
-            <a:pPr indent="0" marL="0">
+            <a:pPr marL="0" indent="0">
               <a:lnSpc>
                 <a:spcPts val="1100"/>
               </a:lnSpc>
@@ -6906,9 +6657,7 @@
             <a:ext cx="2148840" cy="2011680"/>
           </a:xfrm>
           <a:prstGeom prst="rect">
-            <a:avLst>
-              <a:gd name="adj" fmla="val 1818"/>
-            </a:avLst>
+            <a:avLst/>
           </a:prstGeom>
           <a:solidFill>
             <a:srgbClr val="13131D"/>
@@ -6942,7 +6691,7 @@
           <a:bodyPr wrap="square" lIns="0" tIns="0" rIns="0" bIns="0" rtlCol="0" anchor="ctr"/>
           <a:lstStyle/>
           <a:p>
-            <a:pPr indent="0" marL="0">
+            <a:pPr marL="0" indent="0">
               <a:buNone/>
             </a:pPr>
             <a:r>
@@ -6981,7 +6730,7 @@
           <a:bodyPr wrap="square" lIns="0" tIns="0" rIns="0" bIns="0" rtlCol="0" anchor="ctr"/>
           <a:lstStyle/>
           <a:p>
-            <a:pPr indent="0" marL="0">
+            <a:pPr marL="0" indent="0">
               <a:buNone/>
             </a:pPr>
             <a:r>
@@ -7020,7 +6769,7 @@
           <a:bodyPr wrap="square" lIns="0" tIns="0" rIns="0" bIns="0" rtlCol="0" anchor="ctr"/>
           <a:lstStyle/>
           <a:p>
-            <a:pPr indent="0" marL="0">
+            <a:pPr marL="0" indent="0">
               <a:lnSpc>
                 <a:spcPts val="1100"/>
               </a:lnSpc>
@@ -7053,9 +6802,7 @@
             <a:ext cx="2148840" cy="2011680"/>
           </a:xfrm>
           <a:prstGeom prst="rect">
-            <a:avLst>
-              <a:gd name="adj" fmla="val 1818"/>
-            </a:avLst>
+            <a:avLst/>
           </a:prstGeom>
           <a:solidFill>
             <a:srgbClr val="13131D"/>
@@ -7089,7 +6836,7 @@
           <a:bodyPr wrap="square" lIns="0" tIns="0" rIns="0" bIns="0" rtlCol="0" anchor="ctr"/>
           <a:lstStyle/>
           <a:p>
-            <a:pPr indent="0" marL="0">
+            <a:pPr marL="0" indent="0">
               <a:buNone/>
             </a:pPr>
             <a:r>
@@ -7128,7 +6875,7 @@
           <a:bodyPr wrap="square" lIns="0" tIns="0" rIns="0" bIns="0" rtlCol="0" anchor="ctr"/>
           <a:lstStyle/>
           <a:p>
-            <a:pPr indent="0" marL="0">
+            <a:pPr marL="0" indent="0">
               <a:buNone/>
             </a:pPr>
             <a:r>
@@ -7167,7 +6914,7 @@
           <a:bodyPr wrap="square" lIns="0" tIns="0" rIns="0" bIns="0" rtlCol="0" anchor="ctr"/>
           <a:lstStyle/>
           <a:p>
-            <a:pPr indent="0" marL="0">
+            <a:pPr marL="0" indent="0">
               <a:lnSpc>
                 <a:spcPts val="1100"/>
               </a:lnSpc>
@@ -7200,9 +6947,7 @@
             <a:ext cx="5468112" cy="1371600"/>
           </a:xfrm>
           <a:prstGeom prst="rect">
-            <a:avLst>
-              <a:gd name="adj" fmla="val 2667"/>
-            </a:avLst>
+            <a:avLst/>
           </a:prstGeom>
           <a:solidFill>
             <a:srgbClr val="13131D"/>
@@ -7236,7 +6981,7 @@
           <a:bodyPr wrap="square" lIns="0" tIns="0" rIns="0" bIns="0" rtlCol="0" anchor="ctr"/>
           <a:lstStyle/>
           <a:p>
-            <a:pPr indent="0" marL="0">
+            <a:pPr marL="0" indent="0">
               <a:buNone/>
             </a:pPr>
             <a:r>
@@ -7275,7 +7020,7 @@
           <a:bodyPr wrap="square" lIns="0" tIns="0" rIns="0" bIns="0" rtlCol="0" anchor="ctr"/>
           <a:lstStyle/>
           <a:p>
-            <a:pPr indent="0" marL="0">
+            <a:pPr marL="0" indent="0">
               <a:lnSpc>
                 <a:spcPts val="1100"/>
               </a:lnSpc>
@@ -7295,7 +7040,7 @@
             <a:endParaRPr lang="en-US" sz="750" dirty="0"/>
           </a:p>
           <a:p>
-            <a:pPr indent="0" marL="0">
+            <a:pPr marL="0" indent="0">
               <a:lnSpc>
                 <a:spcPts val="1100"/>
               </a:lnSpc>
@@ -7315,7 +7060,7 @@
             <a:endParaRPr lang="en-US" sz="750" dirty="0"/>
           </a:p>
           <a:p>
-            <a:pPr indent="0" marL="0">
+            <a:pPr marL="0" indent="0">
               <a:lnSpc>
                 <a:spcPts val="1100"/>
               </a:lnSpc>
@@ -7348,9 +7093,7 @@
             <a:ext cx="5468112" cy="1371600"/>
           </a:xfrm>
           <a:prstGeom prst="rect">
-            <a:avLst>
-              <a:gd name="adj" fmla="val 2667"/>
-            </a:avLst>
+            <a:avLst/>
           </a:prstGeom>
           <a:solidFill>
             <a:srgbClr val="13131D"/>
@@ -7384,7 +7127,7 @@
           <a:bodyPr wrap="square" lIns="0" tIns="0" rIns="0" bIns="0" rtlCol="0" anchor="ctr"/>
           <a:lstStyle/>
           <a:p>
-            <a:pPr indent="0" marL="0">
+            <a:pPr marL="0" indent="0">
               <a:buNone/>
             </a:pPr>
             <a:r>
@@ -7423,7 +7166,7 @@
           <a:bodyPr wrap="square" lIns="0" tIns="0" rIns="0" bIns="0" rtlCol="0" anchor="ctr"/>
           <a:lstStyle/>
           <a:p>
-            <a:pPr indent="0" marL="0">
+            <a:pPr marL="0" indent="0">
               <a:lnSpc>
                 <a:spcPts val="1100"/>
               </a:lnSpc>
@@ -7443,7 +7186,7 @@
             <a:endParaRPr lang="en-US" sz="750" dirty="0"/>
           </a:p>
           <a:p>
-            <a:pPr indent="0" marL="0">
+            <a:pPr marL="0" indent="0">
               <a:lnSpc>
                 <a:spcPts val="1100"/>
               </a:lnSpc>
@@ -7463,7 +7206,7 @@
             <a:endParaRPr lang="en-US" sz="750" dirty="0"/>
           </a:p>
           <a:p>
-            <a:pPr indent="0" marL="0">
+            <a:pPr marL="0" indent="0">
               <a:lnSpc>
                 <a:spcPts val="1100"/>
               </a:lnSpc>
@@ -7496,9 +7239,7 @@
             <a:ext cx="5468112" cy="1371600"/>
           </a:xfrm>
           <a:prstGeom prst="rect">
-            <a:avLst>
-              <a:gd name="adj" fmla="val 2667"/>
-            </a:avLst>
+            <a:avLst/>
           </a:prstGeom>
           <a:solidFill>
             <a:srgbClr val="13131D"/>
@@ -7532,7 +7273,7 @@
           <a:bodyPr wrap="square" lIns="0" tIns="0" rIns="0" bIns="0" rtlCol="0" anchor="ctr"/>
           <a:lstStyle/>
           <a:p>
-            <a:pPr indent="0" marL="0">
+            <a:pPr marL="0" indent="0">
               <a:buNone/>
             </a:pPr>
             <a:r>
@@ -7571,7 +7312,7 @@
           <a:bodyPr wrap="square" lIns="0" tIns="0" rIns="0" bIns="0" rtlCol="0" anchor="ctr"/>
           <a:lstStyle/>
           <a:p>
-            <a:pPr indent="0" marL="0">
+            <a:pPr marL="0" indent="0">
               <a:lnSpc>
                 <a:spcPts val="1100"/>
               </a:lnSpc>
@@ -7591,7 +7332,7 @@
             <a:endParaRPr lang="en-US" sz="750" dirty="0"/>
           </a:p>
           <a:p>
-            <a:pPr indent="0" marL="0">
+            <a:pPr marL="0" indent="0">
               <a:lnSpc>
                 <a:spcPts val="1100"/>
               </a:lnSpc>
@@ -7611,7 +7352,7 @@
             <a:endParaRPr lang="en-US" sz="750" dirty="0"/>
           </a:p>
           <a:p>
-            <a:pPr indent="0" marL="0">
+            <a:pPr marL="0" indent="0">
               <a:lnSpc>
                 <a:spcPts val="1100"/>
               </a:lnSpc>
@@ -7644,9 +7385,7 @@
             <a:ext cx="5468112" cy="1371600"/>
           </a:xfrm>
           <a:prstGeom prst="rect">
-            <a:avLst>
-              <a:gd name="adj" fmla="val 2667"/>
-            </a:avLst>
+            <a:avLst/>
           </a:prstGeom>
           <a:solidFill>
             <a:srgbClr val="13131D"/>
@@ -7680,7 +7419,7 @@
           <a:bodyPr wrap="square" lIns="0" tIns="0" rIns="0" bIns="0" rtlCol="0" anchor="ctr"/>
           <a:lstStyle/>
           <a:p>
-            <a:pPr indent="0" marL="0">
+            <a:pPr marL="0" indent="0">
               <a:buNone/>
             </a:pPr>
             <a:r>
@@ -7719,7 +7458,7 @@
           <a:bodyPr wrap="square" lIns="0" tIns="0" rIns="0" bIns="0" rtlCol="0" anchor="ctr"/>
           <a:lstStyle/>
           <a:p>
-            <a:pPr indent="0" marL="0">
+            <a:pPr marL="0" indent="0">
               <a:lnSpc>
                 <a:spcPts val="1100"/>
               </a:lnSpc>
@@ -7739,7 +7478,7 @@
             <a:endParaRPr lang="en-US" sz="750" dirty="0"/>
           </a:p>
           <a:p>
-            <a:pPr indent="0" marL="0">
+            <a:pPr marL="0" indent="0">
               <a:lnSpc>
                 <a:spcPts val="1100"/>
               </a:lnSpc>
@@ -7759,7 +7498,7 @@
             <a:endParaRPr lang="en-US" sz="750" dirty="0"/>
           </a:p>
           <a:p>
-            <a:pPr indent="0" marL="0">
+            <a:pPr marL="0" indent="0">
               <a:lnSpc>
                 <a:spcPts val="1100"/>
               </a:lnSpc>
@@ -7817,9 +7556,7 @@
             <a:ext cx="3619195" cy="256032"/>
           </a:xfrm>
           <a:prstGeom prst="rect">
-            <a:avLst>
-              <a:gd name="adj" fmla="val 21429"/>
-            </a:avLst>
+            <a:avLst/>
           </a:prstGeom>
           <a:solidFill>
             <a:srgbClr val="241D09"/>
@@ -7853,7 +7590,7 @@
           <a:bodyPr wrap="square" lIns="0" tIns="0" rIns="0" bIns="0" rtlCol="0" anchor="ctr"/>
           <a:lstStyle/>
           <a:p>
-            <a:pPr indent="0" marL="0">
+            <a:pPr marL="0" indent="0">
               <a:buNone/>
             </a:pPr>
             <a:r>
@@ -7892,7 +7629,7 @@
           <a:bodyPr wrap="square" lIns="0" tIns="0" rIns="0" bIns="0" rtlCol="0" anchor="ctr"/>
           <a:lstStyle/>
           <a:p>
-            <a:pPr indent="0" marL="0">
+            <a:pPr marL="0" indent="0">
               <a:buNone/>
             </a:pPr>
             <a:r>
@@ -7933,10 +7670,34 @@
             <a:tbl>
               <a:tblPr/>
               <a:tblGrid>
-                <a:gridCol w="1280160"/>
-                <a:gridCol w="1280160"/>
-                <a:gridCol w="1280160"/>
-                <a:gridCol w="1280160"/>
+                <a:gridCol w="1280160">
+                  <a:extLst>
+                    <a:ext uri="{9D8B030D-6E8A-4147-A177-3AD203B41FA5}">
+                      <a16:colId xmlns:a16="http://schemas.microsoft.com/office/drawing/2014/main" val="20000"/>
+                    </a:ext>
+                  </a:extLst>
+                </a:gridCol>
+                <a:gridCol w="1280160">
+                  <a:extLst>
+                    <a:ext uri="{9D8B030D-6E8A-4147-A177-3AD203B41FA5}">
+                      <a16:colId xmlns:a16="http://schemas.microsoft.com/office/drawing/2014/main" val="20001"/>
+                    </a:ext>
+                  </a:extLst>
+                </a:gridCol>
+                <a:gridCol w="1280160">
+                  <a:extLst>
+                    <a:ext uri="{9D8B030D-6E8A-4147-A177-3AD203B41FA5}">
+                      <a16:colId xmlns:a16="http://schemas.microsoft.com/office/drawing/2014/main" val="20002"/>
+                    </a:ext>
+                  </a:extLst>
+                </a:gridCol>
+                <a:gridCol w="1280160">
+                  <a:extLst>
+                    <a:ext uri="{9D8B030D-6E8A-4147-A177-3AD203B41FA5}">
+                      <a16:colId xmlns:a16="http://schemas.microsoft.com/office/drawing/2014/main" val="20003"/>
+                    </a:ext>
+                  </a:extLst>
+                </a:gridCol>
               </a:tblGrid>
               <a:tr h="426720">
                 <a:tc>
@@ -7944,7 +7705,7 @@
                     <a:bodyPr/>
                     <a:lstStyle/>
                     <a:p>
-                      <a:pPr algn="l" indent="0" marL="0">
+                      <a:pPr marL="0" indent="0" algn="l">
                         <a:buNone/>
                       </a:pPr>
                       <a:r>
@@ -7958,7 +7719,7 @@
                       <a:endParaRPr lang="en-US" sz="800" dirty="0"/>
                     </a:p>
                   </a:txBody>
-                  <a:tcPr marL="91440" marR="91440" marT="45720" marB="45720" anchor="ctr">
+                  <a:tcPr anchor="ctr">
                     <a:lnL w="12700" cap="flat" cmpd="sng" algn="ctr">
                       <a:solidFill>
                         <a:srgbClr val="242436"/>
@@ -8005,7 +7766,7 @@
                     <a:bodyPr/>
                     <a:lstStyle/>
                     <a:p>
-                      <a:pPr algn="l" indent="0" marL="0">
+                      <a:pPr marL="0" indent="0" algn="l">
                         <a:buNone/>
                       </a:pPr>
                       <a:r>
@@ -8019,7 +7780,7 @@
                       <a:endParaRPr lang="en-US" sz="800" dirty="0"/>
                     </a:p>
                   </a:txBody>
-                  <a:tcPr marL="91440" marR="91440" marT="45720" marB="45720" anchor="ctr">
+                  <a:tcPr anchor="ctr">
                     <a:lnL w="12700" cap="flat" cmpd="sng" algn="ctr">
                       <a:solidFill>
                         <a:srgbClr val="242436"/>
@@ -8066,7 +7827,7 @@
                     <a:bodyPr/>
                     <a:lstStyle/>
                     <a:p>
-                      <a:pPr algn="l" indent="0" marL="0">
+                      <a:pPr marL="0" indent="0" algn="l">
                         <a:buNone/>
                       </a:pPr>
                       <a:r>
@@ -8080,7 +7841,7 @@
                       <a:endParaRPr lang="en-US" sz="800" dirty="0"/>
                     </a:p>
                   </a:txBody>
-                  <a:tcPr marL="91440" marR="91440" marT="45720" marB="45720" anchor="ctr">
+                  <a:tcPr anchor="ctr">
                     <a:lnL w="12700" cap="flat" cmpd="sng" algn="ctr">
                       <a:solidFill>
                         <a:srgbClr val="242436"/>
@@ -8127,7 +7888,7 @@
                     <a:bodyPr/>
                     <a:lstStyle/>
                     <a:p>
-                      <a:pPr algn="l" indent="0" marL="0">
+                      <a:pPr marL="0" indent="0" algn="l">
                         <a:buNone/>
                       </a:pPr>
                       <a:r>
@@ -8141,7 +7902,7 @@
                       <a:endParaRPr lang="en-US" sz="800" dirty="0"/>
                     </a:p>
                   </a:txBody>
-                  <a:tcPr marL="91440" marR="91440" marT="45720" marB="45720" anchor="ctr">
+                  <a:tcPr anchor="ctr">
                     <a:lnL w="12700" cap="flat" cmpd="sng" algn="ctr">
                       <a:solidFill>
                         <a:srgbClr val="242436"/>
@@ -8183,6 +7944,11 @@
                     </a:solidFill>
                   </a:tcPr>
                 </a:tc>
+                <a:extLst>
+                  <a:ext uri="{0D108BD9-81ED-4DB2-BD59-A6C34878D82A}">
+                    <a16:rowId xmlns:a16="http://schemas.microsoft.com/office/drawing/2014/main" val="10000"/>
+                  </a:ext>
+                </a:extLst>
               </a:tr>
               <a:tr h="426720">
                 <a:tc>
@@ -8190,7 +7956,7 @@
                     <a:bodyPr/>
                     <a:lstStyle/>
                     <a:p>
-                      <a:pPr algn="l" indent="0" marL="0">
+                      <a:pPr marL="0" indent="0" algn="l">
                         <a:buNone/>
                       </a:pPr>
                       <a:r>
@@ -8204,7 +7970,7 @@
                       <a:endParaRPr lang="en-US" sz="750" dirty="0"/>
                     </a:p>
                   </a:txBody>
-                  <a:tcPr marL="91440" marR="91440" marT="45720" marB="45720" anchor="ctr">
+                  <a:tcPr anchor="ctr">
                     <a:lnL w="12700" cap="flat" cmpd="sng" algn="ctr">
                       <a:solidFill>
                         <a:srgbClr val="242436"/>
@@ -8248,7 +8014,7 @@
                     <a:bodyPr/>
                     <a:lstStyle/>
                     <a:p>
-                      <a:pPr algn="l" indent="0" marL="0">
+                      <a:pPr marL="0" indent="0" algn="l">
                         <a:buNone/>
                       </a:pPr>
                       <a:r>
@@ -8262,7 +8028,7 @@
                       <a:endParaRPr lang="en-US" sz="750" dirty="0"/>
                     </a:p>
                   </a:txBody>
-                  <a:tcPr marL="91440" marR="91440" marT="45720" marB="45720" anchor="ctr">
+                  <a:tcPr anchor="ctr">
                     <a:lnL w="12700" cap="flat" cmpd="sng" algn="ctr">
                       <a:solidFill>
                         <a:srgbClr val="242436"/>
@@ -8306,7 +8072,7 @@
                     <a:bodyPr/>
                     <a:lstStyle/>
                     <a:p>
-                      <a:pPr algn="l" indent="0" marL="0">
+                      <a:pPr marL="0" indent="0" algn="l">
                         <a:buNone/>
                       </a:pPr>
                       <a:r>
@@ -8320,7 +8086,7 @@
                       <a:endParaRPr lang="en-US" sz="750" dirty="0"/>
                     </a:p>
                   </a:txBody>
-                  <a:tcPr marL="91440" marR="91440" marT="45720" marB="45720" anchor="ctr">
+                  <a:tcPr anchor="ctr">
                     <a:lnL w="12700" cap="flat" cmpd="sng" algn="ctr">
                       <a:solidFill>
                         <a:srgbClr val="242436"/>
@@ -8364,7 +8130,7 @@
                     <a:bodyPr/>
                     <a:lstStyle/>
                     <a:p>
-                      <a:pPr algn="l" indent="0" marL="0">
+                      <a:pPr marL="0" indent="0" algn="l">
                         <a:buNone/>
                       </a:pPr>
                       <a:r>
@@ -8378,7 +8144,7 @@
                       <a:endParaRPr lang="en-US" sz="750" dirty="0"/>
                     </a:p>
                   </a:txBody>
-                  <a:tcPr marL="91440" marR="91440" marT="45720" marB="45720" anchor="ctr">
+                  <a:tcPr anchor="ctr">
                     <a:lnL w="12700" cap="flat" cmpd="sng" algn="ctr">
                       <a:solidFill>
                         <a:srgbClr val="242436"/>
@@ -8417,6 +8183,11 @@
                     </a:lnB>
                   </a:tcPr>
                 </a:tc>
+                <a:extLst>
+                  <a:ext uri="{0D108BD9-81ED-4DB2-BD59-A6C34878D82A}">
+                    <a16:rowId xmlns:a16="http://schemas.microsoft.com/office/drawing/2014/main" val="10001"/>
+                  </a:ext>
+                </a:extLst>
               </a:tr>
               <a:tr h="426720">
                 <a:tc>
@@ -8424,7 +8195,7 @@
                     <a:bodyPr/>
                     <a:lstStyle/>
                     <a:p>
-                      <a:pPr algn="l" indent="0" marL="0">
+                      <a:pPr marL="0" indent="0" algn="l">
                         <a:buNone/>
                       </a:pPr>
                       <a:r>
@@ -8438,7 +8209,7 @@
                       <a:endParaRPr lang="en-US" sz="750" dirty="0"/>
                     </a:p>
                   </a:txBody>
-                  <a:tcPr marL="91440" marR="91440" marT="45720" marB="45720" anchor="ctr">
+                  <a:tcPr anchor="ctr">
                     <a:lnL w="12700" cap="flat" cmpd="sng" algn="ctr">
                       <a:solidFill>
                         <a:srgbClr val="242436"/>
@@ -8482,7 +8253,7 @@
                     <a:bodyPr/>
                     <a:lstStyle/>
                     <a:p>
-                      <a:pPr algn="l" indent="0" marL="0">
+                      <a:pPr marL="0" indent="0" algn="l">
                         <a:buNone/>
                       </a:pPr>
                       <a:r>
@@ -8496,7 +8267,7 @@
                       <a:endParaRPr lang="en-US" sz="750" dirty="0"/>
                     </a:p>
                   </a:txBody>
-                  <a:tcPr marL="91440" marR="91440" marT="45720" marB="45720" anchor="ctr">
+                  <a:tcPr anchor="ctr">
                     <a:lnL w="12700" cap="flat" cmpd="sng" algn="ctr">
                       <a:solidFill>
                         <a:srgbClr val="242436"/>
@@ -8540,7 +8311,7 @@
                     <a:bodyPr/>
                     <a:lstStyle/>
                     <a:p>
-                      <a:pPr algn="l" indent="0" marL="0">
+                      <a:pPr marL="0" indent="0" algn="l">
                         <a:buNone/>
                       </a:pPr>
                       <a:r>
@@ -8554,7 +8325,7 @@
                       <a:endParaRPr lang="en-US" sz="750" dirty="0"/>
                     </a:p>
                   </a:txBody>
-                  <a:tcPr marL="91440" marR="91440" marT="45720" marB="45720" anchor="ctr">
+                  <a:tcPr anchor="ctr">
                     <a:lnL w="12700" cap="flat" cmpd="sng" algn="ctr">
                       <a:solidFill>
                         <a:srgbClr val="242436"/>
@@ -8598,7 +8369,7 @@
                     <a:bodyPr/>
                     <a:lstStyle/>
                     <a:p>
-                      <a:pPr algn="l" indent="0" marL="0">
+                      <a:pPr marL="0" indent="0" algn="l">
                         <a:buNone/>
                       </a:pPr>
                       <a:r>
@@ -8612,7 +8383,7 @@
                       <a:endParaRPr lang="en-US" sz="750" dirty="0"/>
                     </a:p>
                   </a:txBody>
-                  <a:tcPr marL="91440" marR="91440" marT="45720" marB="45720" anchor="ctr">
+                  <a:tcPr anchor="ctr">
                     <a:lnL w="12700" cap="flat" cmpd="sng" algn="ctr">
                       <a:solidFill>
                         <a:srgbClr val="242436"/>
@@ -8651,6 +8422,11 @@
                     </a:lnB>
                   </a:tcPr>
                 </a:tc>
+                <a:extLst>
+                  <a:ext uri="{0D108BD9-81ED-4DB2-BD59-A6C34878D82A}">
+                    <a16:rowId xmlns:a16="http://schemas.microsoft.com/office/drawing/2014/main" val="10002"/>
+                  </a:ext>
+                </a:extLst>
               </a:tr>
               <a:tr h="426720">
                 <a:tc>
@@ -8658,7 +8434,7 @@
                     <a:bodyPr/>
                     <a:lstStyle/>
                     <a:p>
-                      <a:pPr algn="l" indent="0" marL="0">
+                      <a:pPr marL="0" indent="0" algn="l">
                         <a:buNone/>
                       </a:pPr>
                       <a:r>
@@ -8672,7 +8448,7 @@
                       <a:endParaRPr lang="en-US" sz="750" dirty="0"/>
                     </a:p>
                   </a:txBody>
-                  <a:tcPr marL="91440" marR="91440" marT="45720" marB="45720" anchor="ctr">
+                  <a:tcPr anchor="ctr">
                     <a:lnL w="12700" cap="flat" cmpd="sng" algn="ctr">
                       <a:solidFill>
                         <a:srgbClr val="242436"/>
@@ -8716,7 +8492,7 @@
                     <a:bodyPr/>
                     <a:lstStyle/>
                     <a:p>
-                      <a:pPr algn="l" indent="0" marL="0">
+                      <a:pPr marL="0" indent="0" algn="l">
                         <a:buNone/>
                       </a:pPr>
                       <a:r>
@@ -8730,7 +8506,7 @@
                       <a:endParaRPr lang="en-US" sz="750" dirty="0"/>
                     </a:p>
                   </a:txBody>
-                  <a:tcPr marL="91440" marR="91440" marT="45720" marB="45720" anchor="ctr">
+                  <a:tcPr anchor="ctr">
                     <a:lnL w="12700" cap="flat" cmpd="sng" algn="ctr">
                       <a:solidFill>
                         <a:srgbClr val="242436"/>
@@ -8774,7 +8550,7 @@
                     <a:bodyPr/>
                     <a:lstStyle/>
                     <a:p>
-                      <a:pPr algn="l" indent="0" marL="0">
+                      <a:pPr marL="0" indent="0" algn="l">
                         <a:buNone/>
                       </a:pPr>
                       <a:r>
@@ -8788,7 +8564,7 @@
                       <a:endParaRPr lang="en-US" sz="750" dirty="0"/>
                     </a:p>
                   </a:txBody>
-                  <a:tcPr marL="91440" marR="91440" marT="45720" marB="45720" anchor="ctr">
+                  <a:tcPr anchor="ctr">
                     <a:lnL w="12700" cap="flat" cmpd="sng" algn="ctr">
                       <a:solidFill>
                         <a:srgbClr val="242436"/>
@@ -8832,7 +8608,7 @@
                     <a:bodyPr/>
                     <a:lstStyle/>
                     <a:p>
-                      <a:pPr algn="l" indent="0" marL="0">
+                      <a:pPr marL="0" indent="0" algn="l">
                         <a:buNone/>
                       </a:pPr>
                       <a:r>
@@ -8846,7 +8622,7 @@
                       <a:endParaRPr lang="en-US" sz="750" dirty="0"/>
                     </a:p>
                   </a:txBody>
-                  <a:tcPr marL="91440" marR="91440" marT="45720" marB="45720" anchor="ctr">
+                  <a:tcPr anchor="ctr">
                     <a:lnL w="12700" cap="flat" cmpd="sng" algn="ctr">
                       <a:solidFill>
                         <a:srgbClr val="242436"/>
@@ -8885,6 +8661,11 @@
                     </a:lnB>
                   </a:tcPr>
                 </a:tc>
+                <a:extLst>
+                  <a:ext uri="{0D108BD9-81ED-4DB2-BD59-A6C34878D82A}">
+                    <a16:rowId xmlns:a16="http://schemas.microsoft.com/office/drawing/2014/main" val="10003"/>
+                  </a:ext>
+                </a:extLst>
               </a:tr>
               <a:tr h="426720">
                 <a:tc>
@@ -8892,7 +8673,7 @@
                     <a:bodyPr/>
                     <a:lstStyle/>
                     <a:p>
-                      <a:pPr algn="l" indent="0" marL="0">
+                      <a:pPr marL="0" indent="0" algn="l">
                         <a:buNone/>
                       </a:pPr>
                       <a:r>
@@ -8906,7 +8687,7 @@
                       <a:endParaRPr lang="en-US" sz="750" dirty="0"/>
                     </a:p>
                   </a:txBody>
-                  <a:tcPr marL="91440" marR="91440" marT="45720" marB="45720" anchor="ctr">
+                  <a:tcPr anchor="ctr">
                     <a:lnL w="12700" cap="flat" cmpd="sng" algn="ctr">
                       <a:solidFill>
                         <a:srgbClr val="242436"/>
@@ -8950,7 +8731,7 @@
                     <a:bodyPr/>
                     <a:lstStyle/>
                     <a:p>
-                      <a:pPr algn="l" indent="0" marL="0">
+                      <a:pPr marL="0" indent="0" algn="l">
                         <a:buNone/>
                       </a:pPr>
                       <a:r>
@@ -8964,7 +8745,7 @@
                       <a:endParaRPr lang="en-US" sz="750" dirty="0"/>
                     </a:p>
                   </a:txBody>
-                  <a:tcPr marL="91440" marR="91440" marT="45720" marB="45720" anchor="ctr">
+                  <a:tcPr anchor="ctr">
                     <a:lnL w="12700" cap="flat" cmpd="sng" algn="ctr">
                       <a:solidFill>
                         <a:srgbClr val="242436"/>
@@ -9008,7 +8789,7 @@
                     <a:bodyPr/>
                     <a:lstStyle/>
                     <a:p>
-                      <a:pPr algn="l" indent="0" marL="0">
+                      <a:pPr marL="0" indent="0" algn="l">
                         <a:buNone/>
                       </a:pPr>
                       <a:r>
@@ -9022,7 +8803,7 @@
                       <a:endParaRPr lang="en-US" sz="750" dirty="0"/>
                     </a:p>
                   </a:txBody>
-                  <a:tcPr marL="91440" marR="91440" marT="45720" marB="45720" anchor="ctr">
+                  <a:tcPr anchor="ctr">
                     <a:lnL w="12700" cap="flat" cmpd="sng" algn="ctr">
                       <a:solidFill>
                         <a:srgbClr val="242436"/>
@@ -9066,7 +8847,7 @@
                     <a:bodyPr/>
                     <a:lstStyle/>
                     <a:p>
-                      <a:pPr algn="l" indent="0" marL="0">
+                      <a:pPr marL="0" indent="0" algn="l">
                         <a:buNone/>
                       </a:pPr>
                       <a:r>
@@ -9080,7 +8861,7 @@
                       <a:endParaRPr lang="en-US" sz="750" dirty="0"/>
                     </a:p>
                   </a:txBody>
-                  <a:tcPr marL="91440" marR="91440" marT="45720" marB="45720" anchor="ctr">
+                  <a:tcPr anchor="ctr">
                     <a:lnL w="12700" cap="flat" cmpd="sng" algn="ctr">
                       <a:solidFill>
                         <a:srgbClr val="242436"/>
@@ -9119,6 +8900,11 @@
                     </a:lnB>
                   </a:tcPr>
                 </a:tc>
+                <a:extLst>
+                  <a:ext uri="{0D108BD9-81ED-4DB2-BD59-A6C34878D82A}">
+                    <a16:rowId xmlns:a16="http://schemas.microsoft.com/office/drawing/2014/main" val="10004"/>
+                  </a:ext>
+                </a:extLst>
               </a:tr>
               <a:tr h="426720">
                 <a:tc>
@@ -9126,7 +8912,7 @@
                     <a:bodyPr/>
                     <a:lstStyle/>
                     <a:p>
-                      <a:pPr algn="l" indent="0" marL="0">
+                      <a:pPr marL="0" indent="0" algn="l">
                         <a:buNone/>
                       </a:pPr>
                       <a:r>
@@ -9140,7 +8926,7 @@
                       <a:endParaRPr lang="en-US" sz="750" dirty="0"/>
                     </a:p>
                   </a:txBody>
-                  <a:tcPr marL="91440" marR="91440" marT="45720" marB="45720" anchor="ctr">
+                  <a:tcPr anchor="ctr">
                     <a:lnL w="12700" cap="flat" cmpd="sng" algn="ctr">
                       <a:solidFill>
                         <a:srgbClr val="242436"/>
@@ -9184,7 +8970,7 @@
                     <a:bodyPr/>
                     <a:lstStyle/>
                     <a:p>
-                      <a:pPr algn="l" indent="0" marL="0">
+                      <a:pPr marL="0" indent="0" algn="l">
                         <a:buNone/>
                       </a:pPr>
                       <a:r>
@@ -9198,7 +8984,7 @@
                       <a:endParaRPr lang="en-US" sz="750" dirty="0"/>
                     </a:p>
                   </a:txBody>
-                  <a:tcPr marL="91440" marR="91440" marT="45720" marB="45720" anchor="ctr">
+                  <a:tcPr anchor="ctr">
                     <a:lnL w="12700" cap="flat" cmpd="sng" algn="ctr">
                       <a:solidFill>
                         <a:srgbClr val="242436"/>
@@ -9242,7 +9028,7 @@
                     <a:bodyPr/>
                     <a:lstStyle/>
                     <a:p>
-                      <a:pPr algn="l" indent="0" marL="0">
+                      <a:pPr marL="0" indent="0" algn="l">
                         <a:buNone/>
                       </a:pPr>
                       <a:r>
@@ -9256,7 +9042,7 @@
                       <a:endParaRPr lang="en-US" sz="750" dirty="0"/>
                     </a:p>
                   </a:txBody>
-                  <a:tcPr marL="91440" marR="91440" marT="45720" marB="45720" anchor="ctr">
+                  <a:tcPr anchor="ctr">
                     <a:lnL w="12700" cap="flat" cmpd="sng" algn="ctr">
                       <a:solidFill>
                         <a:srgbClr val="242436"/>
@@ -9300,7 +9086,7 @@
                     <a:bodyPr/>
                     <a:lstStyle/>
                     <a:p>
-                      <a:pPr algn="l" indent="0" marL="0">
+                      <a:pPr marL="0" indent="0" algn="l">
                         <a:buNone/>
                       </a:pPr>
                       <a:r>
@@ -9314,7 +9100,7 @@
                       <a:endParaRPr lang="en-US" sz="750" dirty="0"/>
                     </a:p>
                   </a:txBody>
-                  <a:tcPr marL="91440" marR="91440" marT="45720" marB="45720" anchor="ctr">
+                  <a:tcPr anchor="ctr">
                     <a:lnL w="12700" cap="flat" cmpd="sng" algn="ctr">
                       <a:solidFill>
                         <a:srgbClr val="242436"/>
@@ -9353,6 +9139,11 @@
                     </a:lnB>
                   </a:tcPr>
                 </a:tc>
+                <a:extLst>
+                  <a:ext uri="{0D108BD9-81ED-4DB2-BD59-A6C34878D82A}">
+                    <a16:rowId xmlns:a16="http://schemas.microsoft.com/office/drawing/2014/main" val="10005"/>
+                  </a:ext>
+                </a:extLst>
               </a:tr>
             </a:tbl>
           </a:graphicData>
@@ -9370,9 +9161,7 @@
             <a:ext cx="5120640" cy="2377440"/>
           </a:xfrm>
           <a:prstGeom prst="rect">
-            <a:avLst>
-              <a:gd name="adj" fmla="val 1538"/>
-            </a:avLst>
+            <a:avLst/>
           </a:prstGeom>
           <a:solidFill>
             <a:srgbClr val="101624"/>
@@ -9387,7 +9176,7 @@
       </p:sp>
       <p:sp>
         <p:nvSpPr>
-          <p:cNvPr id="7" name="Shape 4"/>
+          <p:cNvPr id="5" name="Shape 4"/>
           <p:cNvSpPr/>
           <p:nvPr/>
         </p:nvSpPr>
@@ -9397,9 +9186,7 @@
             <a:ext cx="2734056" cy="256032"/>
           </a:xfrm>
           <a:prstGeom prst="rect">
-            <a:avLst>
-              <a:gd name="adj" fmla="val 21429"/>
-            </a:avLst>
+            <a:avLst/>
           </a:prstGeom>
           <a:solidFill>
             <a:srgbClr val="241D09"/>
@@ -9433,7 +9220,7 @@
           <a:bodyPr wrap="square" lIns="0" tIns="0" rIns="0" bIns="0" rtlCol="0" anchor="ctr"/>
           <a:lstStyle/>
           <a:p>
-            <a:pPr indent="0" marL="0">
+            <a:pPr marL="0" indent="0">
               <a:buNone/>
             </a:pPr>
             <a:r>
@@ -9472,7 +9259,7 @@
           <a:bodyPr wrap="square" lIns="0" tIns="0" rIns="0" bIns="0" rtlCol="0" anchor="ctr"/>
           <a:lstStyle/>
           <a:p>
-            <a:pPr indent="0" marL="0">
+            <a:pPr marL="0" indent="0">
               <a:lnSpc>
                 <a:spcPts val="1200"/>
               </a:lnSpc>
@@ -9492,7 +9279,7 @@
             <a:endParaRPr lang="en-US" sz="800" dirty="0"/>
           </a:p>
           <a:p>
-            <a:pPr indent="0" marL="0">
+            <a:pPr marL="0" indent="0">
               <a:lnSpc>
                 <a:spcPts val="1200"/>
               </a:lnSpc>
@@ -9512,7 +9299,7 @@
             <a:endParaRPr lang="en-US" sz="800" dirty="0"/>
           </a:p>
           <a:p>
-            <a:pPr indent="0" marL="0">
+            <a:pPr marL="0" indent="0">
               <a:lnSpc>
                 <a:spcPts val="1200"/>
               </a:lnSpc>
@@ -9532,7 +9319,7 @@
             <a:endParaRPr lang="en-US" sz="800" dirty="0"/>
           </a:p>
           <a:p>
-            <a:pPr indent="0" marL="0">
+            <a:pPr marL="0" indent="0">
               <a:lnSpc>
                 <a:spcPts val="1200"/>
               </a:lnSpc>
@@ -9565,9 +9352,7 @@
             <a:ext cx="5788152" cy="5120640"/>
           </a:xfrm>
           <a:prstGeom prst="rect">
-            <a:avLst>
-              <a:gd name="adj" fmla="val 714"/>
-            </a:avLst>
+            <a:avLst/>
           </a:prstGeom>
           <a:solidFill>
             <a:srgbClr val="13131D"/>
@@ -9582,15 +9367,15 @@
       </p:sp>
       <p:pic>
         <p:nvPicPr>
-          <p:cNvPr id="11" name="Image 0" descr="D:\hackathon_elicit_acm\assets\workbench_feed.png">    </p:cNvPr>
+          <p:cNvPr id="11" name="Image 0" descr="D:\hackathon_elicit_acm\assets\workbench_feed.png"/>
           <p:cNvPicPr>
             <a:picLocks noChangeAspect="1"/>
           </p:cNvPicPr>
           <p:nvPr/>
         </p:nvPicPr>
         <p:blipFill>
-          <a:blip r:embed="rId1"/>
-          <a:srcRect l="0" r="0" t="0" b="0"/>
+          <a:blip r:embed="rId3"/>
+          <a:srcRect/>
           <a:stretch/>
         </p:blipFill>
         <p:spPr>
@@ -9615,9 +9400,7 @@
             <a:ext cx="3297326" cy="256032"/>
           </a:xfrm>
           <a:prstGeom prst="rect">
-            <a:avLst>
-              <a:gd name="adj" fmla="val 21429"/>
-            </a:avLst>
+            <a:avLst/>
           </a:prstGeom>
           <a:solidFill>
             <a:srgbClr val="241D09"/>
@@ -9651,7 +9434,7 @@
           <a:bodyPr wrap="square" lIns="0" tIns="0" rIns="0" bIns="0" rtlCol="0" anchor="ctr"/>
           <a:lstStyle/>
           <a:p>
-            <a:pPr indent="0" marL="0">
+            <a:pPr marL="0" indent="0">
               <a:buNone/>
             </a:pPr>
             <a:r>
@@ -9690,7 +9473,7 @@
           <a:bodyPr wrap="square" lIns="0" tIns="0" rIns="0" bIns="0" rtlCol="0" anchor="ctr"/>
           <a:lstStyle/>
           <a:p>
-            <a:pPr indent="0" marL="0">
+            <a:pPr marL="0" indent="0">
               <a:buNone/>
             </a:pPr>
             <a:r>
@@ -9745,9 +9528,7 @@
             <a:ext cx="4584802" cy="256032"/>
           </a:xfrm>
           <a:prstGeom prst="rect">
-            <a:avLst>
-              <a:gd name="adj" fmla="val 21429"/>
-            </a:avLst>
+            <a:avLst/>
           </a:prstGeom>
           <a:solidFill>
             <a:srgbClr val="241D09"/>
@@ -9781,7 +9562,7 @@
           <a:bodyPr wrap="square" lIns="0" tIns="0" rIns="0" bIns="0" rtlCol="0" anchor="ctr"/>
           <a:lstStyle/>
           <a:p>
-            <a:pPr indent="0" marL="0">
+            <a:pPr marL="0" indent="0">
               <a:buNone/>
             </a:pPr>
             <a:r>
@@ -9820,7 +9601,7 @@
           <a:bodyPr wrap="square" lIns="0" tIns="0" rIns="0" bIns="0" rtlCol="0" anchor="ctr"/>
           <a:lstStyle/>
           <a:p>
-            <a:pPr indent="0" marL="0">
+            <a:pPr marL="0" indent="0">
               <a:buNone/>
             </a:pPr>
             <a:r>
@@ -9850,9 +9631,7 @@
             <a:ext cx="5394960" cy="5120640"/>
           </a:xfrm>
           <a:prstGeom prst="rect">
-            <a:avLst>
-              <a:gd name="adj" fmla="val 714"/>
-            </a:avLst>
+            <a:avLst/>
           </a:prstGeom>
           <a:solidFill>
             <a:srgbClr val="13131D"/>
@@ -9877,9 +9656,7 @@
             <a:ext cx="3297326" cy="256032"/>
           </a:xfrm>
           <a:prstGeom prst="rect">
-            <a:avLst>
-              <a:gd name="adj" fmla="val 21429"/>
-            </a:avLst>
+            <a:avLst/>
           </a:prstGeom>
           <a:solidFill>
             <a:srgbClr val="102030"/>
@@ -9913,7 +9690,7 @@
           <a:bodyPr wrap="square" lIns="0" tIns="0" rIns="0" bIns="0" rtlCol="0" anchor="ctr"/>
           <a:lstStyle/>
           <a:p>
-            <a:pPr indent="0" marL="0">
+            <a:pPr marL="0" indent="0">
               <a:buNone/>
             </a:pPr>
             <a:r>
@@ -9952,7 +9729,7 @@
           <a:bodyPr wrap="square" lIns="0" tIns="0" rIns="0" bIns="0" rtlCol="0" anchor="ctr"/>
           <a:lstStyle/>
           <a:p>
-            <a:pPr indent="0" marL="0">
+            <a:pPr marL="0" indent="0">
               <a:lnSpc>
                 <a:spcPts val="1300"/>
               </a:lnSpc>
@@ -9972,7 +9749,7 @@
             <a:endParaRPr lang="en-US" sz="850" dirty="0"/>
           </a:p>
           <a:p>
-            <a:pPr indent="0" marL="0">
+            <a:pPr marL="0" indent="0">
               <a:lnSpc>
                 <a:spcPts val="1300"/>
               </a:lnSpc>
@@ -9981,7 +9758,7 @@
             <a:endParaRPr lang="en-US" sz="850" dirty="0"/>
           </a:p>
           <a:p>
-            <a:pPr indent="0" marL="0">
+            <a:pPr marL="0" indent="0">
               <a:lnSpc>
                 <a:spcPts val="1300"/>
               </a:lnSpc>
@@ -10001,7 +9778,7 @@
             <a:endParaRPr lang="en-US" sz="850" dirty="0"/>
           </a:p>
           <a:p>
-            <a:pPr indent="0" marL="0">
+            <a:pPr marL="0" indent="0">
               <a:lnSpc>
                 <a:spcPts val="1300"/>
               </a:lnSpc>
@@ -10010,7 +9787,7 @@
             <a:endParaRPr lang="en-US" sz="850" dirty="0"/>
           </a:p>
           <a:p>
-            <a:pPr indent="0" marL="0">
+            <a:pPr marL="0" indent="0">
               <a:lnSpc>
                 <a:spcPts val="1300"/>
               </a:lnSpc>
@@ -10030,7 +9807,7 @@
             <a:endParaRPr lang="en-US" sz="850" dirty="0"/>
           </a:p>
           <a:p>
-            <a:pPr indent="0" marL="0">
+            <a:pPr marL="0" indent="0">
               <a:lnSpc>
                 <a:spcPts val="1300"/>
               </a:lnSpc>
@@ -10039,7 +9816,7 @@
             <a:endParaRPr lang="en-US" sz="850" dirty="0"/>
           </a:p>
           <a:p>
-            <a:pPr indent="0" marL="0">
+            <a:pPr marL="0" indent="0">
               <a:lnSpc>
                 <a:spcPts val="1300"/>
               </a:lnSpc>
@@ -10072,9 +9849,7 @@
             <a:ext cx="5394960" cy="5120640"/>
           </a:xfrm>
           <a:prstGeom prst="rect">
-            <a:avLst>
-              <a:gd name="adj" fmla="val 714"/>
-            </a:avLst>
+            <a:avLst/>
           </a:prstGeom>
           <a:solidFill>
             <a:srgbClr val="13131D"/>
@@ -10099,9 +9874,7 @@
             <a:ext cx="3136392" cy="256032"/>
           </a:xfrm>
           <a:prstGeom prst="rect">
-            <a:avLst>
-              <a:gd name="adj" fmla="val 21429"/>
-            </a:avLst>
+            <a:avLst/>
           </a:prstGeom>
           <a:solidFill>
             <a:srgbClr val="0D2818"/>
@@ -10135,7 +9908,7 @@
           <a:bodyPr wrap="square" lIns="0" tIns="0" rIns="0" bIns="0" rtlCol="0" anchor="ctr"/>
           <a:lstStyle/>
           <a:p>
-            <a:pPr indent="0" marL="0">
+            <a:pPr marL="0" indent="0">
               <a:buNone/>
             </a:pPr>
             <a:r>
@@ -10174,7 +9947,7 @@
           <a:bodyPr wrap="square" lIns="0" tIns="0" rIns="0" bIns="0" rtlCol="0" anchor="ctr"/>
           <a:lstStyle/>
           <a:p>
-            <a:pPr indent="0" marL="0">
+            <a:pPr marL="0" indent="0">
               <a:lnSpc>
                 <a:spcPts val="1300"/>
               </a:lnSpc>
@@ -10194,7 +9967,7 @@
             <a:endParaRPr lang="en-US" sz="850" dirty="0"/>
           </a:p>
           <a:p>
-            <a:pPr indent="0" marL="0">
+            <a:pPr marL="0" indent="0">
               <a:lnSpc>
                 <a:spcPts val="1300"/>
               </a:lnSpc>
@@ -10203,7 +9976,7 @@
             <a:endParaRPr lang="en-US" sz="850" dirty="0"/>
           </a:p>
           <a:p>
-            <a:pPr indent="0" marL="0">
+            <a:pPr marL="0" indent="0">
               <a:lnSpc>
                 <a:spcPts val="1300"/>
               </a:lnSpc>
@@ -10223,7 +9996,7 @@
             <a:endParaRPr lang="en-US" sz="850" dirty="0"/>
           </a:p>
           <a:p>
-            <a:pPr indent="0" marL="0">
+            <a:pPr marL="0" indent="0">
               <a:lnSpc>
                 <a:spcPts val="1300"/>
               </a:lnSpc>
@@ -10232,7 +10005,7 @@
             <a:endParaRPr lang="en-US" sz="850" dirty="0"/>
           </a:p>
           <a:p>
-            <a:pPr indent="0" marL="0">
+            <a:pPr marL="0" indent="0">
               <a:lnSpc>
                 <a:spcPts val="1300"/>
               </a:lnSpc>
@@ -10252,7 +10025,7 @@
             <a:endParaRPr lang="en-US" sz="850" dirty="0"/>
           </a:p>
           <a:p>
-            <a:pPr indent="0" marL="0">
+            <a:pPr marL="0" indent="0">
               <a:lnSpc>
                 <a:spcPts val="1300"/>
               </a:lnSpc>
@@ -10261,7 +10034,7 @@
             <a:endParaRPr lang="en-US" sz="850" dirty="0"/>
           </a:p>
           <a:p>
-            <a:pPr indent="0" marL="0">
+            <a:pPr marL="0" indent="0">
               <a:lnSpc>
                 <a:spcPts val="1300"/>
               </a:lnSpc>
@@ -10319,9 +10092,7 @@
             <a:ext cx="4101998" cy="256032"/>
           </a:xfrm>
           <a:prstGeom prst="rect">
-            <a:avLst>
-              <a:gd name="adj" fmla="val 21429"/>
-            </a:avLst>
+            <a:avLst/>
           </a:prstGeom>
           <a:solidFill>
             <a:srgbClr val="241D09"/>
@@ -10355,7 +10126,7 @@
           <a:bodyPr wrap="square" lIns="0" tIns="0" rIns="0" bIns="0" rtlCol="0" anchor="ctr"/>
           <a:lstStyle/>
           <a:p>
-            <a:pPr indent="0" marL="0">
+            <a:pPr marL="0" indent="0">
               <a:buNone/>
             </a:pPr>
             <a:r>
@@ -10394,7 +10165,7 @@
           <a:bodyPr wrap="square" lIns="0" tIns="0" rIns="0" bIns="0" rtlCol="0" anchor="ctr"/>
           <a:lstStyle/>
           <a:p>
-            <a:pPr indent="0" marL="0">
+            <a:pPr marL="0" indent="0">
               <a:buNone/>
             </a:pPr>
             <a:r>
@@ -10424,9 +10195,7 @@
             <a:ext cx="5468112" cy="1920240"/>
           </a:xfrm>
           <a:prstGeom prst="rect">
-            <a:avLst>
-              <a:gd name="adj" fmla="val 1905"/>
-            </a:avLst>
+            <a:avLst/>
           </a:prstGeom>
           <a:solidFill>
             <a:srgbClr val="13131D"/>
@@ -10460,7 +10229,7 @@
           <a:bodyPr wrap="square" lIns="0" tIns="0" rIns="0" bIns="0" rtlCol="0" anchor="ctr"/>
           <a:lstStyle/>
           <a:p>
-            <a:pPr indent="0" marL="0">
+            <a:pPr marL="0" indent="0">
               <a:buNone/>
             </a:pPr>
             <a:r>
@@ -10499,7 +10268,7 @@
           <a:bodyPr wrap="square" lIns="0" tIns="0" rIns="0" bIns="0" rtlCol="0" anchor="ctr"/>
           <a:lstStyle/>
           <a:p>
-            <a:pPr indent="0" marL="0">
+            <a:pPr marL="0" indent="0">
               <a:lnSpc>
                 <a:spcPts val="1100"/>
               </a:lnSpc>
@@ -10532,9 +10301,7 @@
             <a:ext cx="5468112" cy="1920240"/>
           </a:xfrm>
           <a:prstGeom prst="rect">
-            <a:avLst>
-              <a:gd name="adj" fmla="val 1905"/>
-            </a:avLst>
+            <a:avLst/>
           </a:prstGeom>
           <a:solidFill>
             <a:srgbClr val="13131D"/>
@@ -10568,7 +10335,7 @@
           <a:bodyPr wrap="square" lIns="0" tIns="0" rIns="0" bIns="0" rtlCol="0" anchor="ctr"/>
           <a:lstStyle/>
           <a:p>
-            <a:pPr indent="0" marL="0">
+            <a:pPr marL="0" indent="0">
               <a:buNone/>
             </a:pPr>
             <a:r>
@@ -10607,7 +10374,7 @@
           <a:bodyPr wrap="square" lIns="0" tIns="0" rIns="0" bIns="0" rtlCol="0" anchor="ctr"/>
           <a:lstStyle/>
           <a:p>
-            <a:pPr indent="0" marL="0">
+            <a:pPr marL="0" indent="0">
               <a:lnSpc>
                 <a:spcPts val="1100"/>
               </a:lnSpc>
@@ -10640,9 +10407,7 @@
             <a:ext cx="5468112" cy="1920240"/>
           </a:xfrm>
           <a:prstGeom prst="rect">
-            <a:avLst>
-              <a:gd name="adj" fmla="val 1905"/>
-            </a:avLst>
+            <a:avLst/>
           </a:prstGeom>
           <a:solidFill>
             <a:srgbClr val="13131D"/>
@@ -10676,7 +10441,7 @@
           <a:bodyPr wrap="square" lIns="0" tIns="0" rIns="0" bIns="0" rtlCol="0" anchor="ctr"/>
           <a:lstStyle/>
           <a:p>
-            <a:pPr indent="0" marL="0">
+            <a:pPr marL="0" indent="0">
               <a:buNone/>
             </a:pPr>
             <a:r>
@@ -10715,7 +10480,7 @@
           <a:bodyPr wrap="square" lIns="0" tIns="0" rIns="0" bIns="0" rtlCol="0" anchor="ctr"/>
           <a:lstStyle/>
           <a:p>
-            <a:pPr indent="0" marL="0">
+            <a:pPr marL="0" indent="0">
               <a:lnSpc>
                 <a:spcPts val="1100"/>
               </a:lnSpc>
@@ -10748,9 +10513,7 @@
             <a:ext cx="5468112" cy="1920240"/>
           </a:xfrm>
           <a:prstGeom prst="rect">
-            <a:avLst>
-              <a:gd name="adj" fmla="val 1905"/>
-            </a:avLst>
+            <a:avLst/>
           </a:prstGeom>
           <a:solidFill>
             <a:srgbClr val="13131D"/>
@@ -10784,7 +10547,7 @@
           <a:bodyPr wrap="square" lIns="0" tIns="0" rIns="0" bIns="0" rtlCol="0" anchor="ctr"/>
           <a:lstStyle/>
           <a:p>
-            <a:pPr indent="0" marL="0">
+            <a:pPr marL="0" indent="0">
               <a:buNone/>
             </a:pPr>
             <a:r>
@@ -10823,7 +10586,7 @@
           <a:bodyPr wrap="square" lIns="0" tIns="0" rIns="0" bIns="0" rtlCol="0" anchor="ctr"/>
           <a:lstStyle/>
           <a:p>
-            <a:pPr indent="0" marL="0">
+            <a:pPr marL="0" indent="0">
               <a:lnSpc>
                 <a:spcPts val="1100"/>
               </a:lnSpc>
@@ -10856,9 +10619,7 @@
             <a:ext cx="11094415" cy="822960"/>
           </a:xfrm>
           <a:prstGeom prst="rect">
-            <a:avLst>
-              <a:gd name="adj" fmla="val 4444"/>
-            </a:avLst>
+            <a:avLst/>
           </a:prstGeom>
           <a:solidFill>
             <a:srgbClr val="101624"/>
@@ -10892,7 +10653,7 @@
           <a:bodyPr wrap="square" lIns="0" tIns="0" rIns="0" bIns="0" rtlCol="0" anchor="ctr"/>
           <a:lstStyle/>
           <a:p>
-            <a:pPr algn="ctr" indent="0" marL="0">
+            <a:pPr marL="0" indent="0" algn="ctr">
               <a:buNone/>
             </a:pPr>
             <a:r>
@@ -11211,4 +10972,319 @@
     </a:ext>
   </a:extLst>
 </a:theme>
+</file>
+
+<file path=ppt/theme/theme2.xml><?xml version="1.0" encoding="utf-8"?>
+<a:theme xmlns:a="http://schemas.openxmlformats.org/drawingml/2006/main" name="Office Theme">
+  <a:themeElements>
+    <a:clrScheme name="Office">
+      <a:dk1>
+        <a:sysClr val="windowText" lastClr="000000"/>
+      </a:dk1>
+      <a:lt1>
+        <a:sysClr val="window" lastClr="FFFFFF"/>
+      </a:lt1>
+      <a:dk2>
+        <a:srgbClr val="0E2841"/>
+      </a:dk2>
+      <a:lt2>
+        <a:srgbClr val="E8E8E8"/>
+      </a:lt2>
+      <a:accent1>
+        <a:srgbClr val="156082"/>
+      </a:accent1>
+      <a:accent2>
+        <a:srgbClr val="E97132"/>
+      </a:accent2>
+      <a:accent3>
+        <a:srgbClr val="196B24"/>
+      </a:accent3>
+      <a:accent4>
+        <a:srgbClr val="0F9ED5"/>
+      </a:accent4>
+      <a:accent5>
+        <a:srgbClr val="A02B93"/>
+      </a:accent5>
+      <a:accent6>
+        <a:srgbClr val="4EA72E"/>
+      </a:accent6>
+      <a:hlink>
+        <a:srgbClr val="467886"/>
+      </a:hlink>
+      <a:folHlink>
+        <a:srgbClr val="96607D"/>
+      </a:folHlink>
+    </a:clrScheme>
+    <a:fontScheme name="Office">
+      <a:majorFont>
+        <a:latin typeface="Aptos Display" panose="02110004020202020204"/>
+        <a:ea typeface=""/>
+        <a:cs typeface=""/>
+        <a:font script="Jpan" typeface="游ゴシック Light"/>
+        <a:font script="Hang" typeface="맑은 고딕"/>
+        <a:font script="Hans" typeface="等线 Light"/>
+        <a:font script="Hant" typeface="新細明體"/>
+        <a:font script="Arab" typeface="Times New Roman"/>
+        <a:font script="Hebr" typeface="Times New Roman"/>
+        <a:font script="Thai" typeface="Angsana New"/>
+        <a:font script="Ethi" typeface="Nyala"/>
+        <a:font script="Beng" typeface="Vrinda"/>
+        <a:font script="Gujr" typeface="Shruti"/>
+        <a:font script="Khmr" typeface="MoolBoran"/>
+        <a:font script="Knda" typeface="Tunga"/>
+        <a:font script="Guru" typeface="Raavi"/>
+        <a:font script="Cans" typeface="Euphemia"/>
+        <a:font script="Cher" typeface="Plantagenet Cherokee"/>
+        <a:font script="Yiii" typeface="Microsoft Yi Baiti"/>
+        <a:font script="Tibt" typeface="Microsoft Himalaya"/>
+        <a:font script="Thaa" typeface="MV Boli"/>
+        <a:font script="Deva" typeface="Mangal"/>
+        <a:font script="Telu" typeface="Gautami"/>
+        <a:font script="Taml" typeface="Latha"/>
+        <a:font script="Syrc" typeface="Estrangelo Edessa"/>
+        <a:font script="Orya" typeface="Kalinga"/>
+        <a:font script="Mlym" typeface="Kartika"/>
+        <a:font script="Laoo" typeface="DokChampa"/>
+        <a:font script="Sinh" typeface="Iskoola Pota"/>
+        <a:font script="Mong" typeface="Mongolian Baiti"/>
+        <a:font script="Viet" typeface="Times New Roman"/>
+        <a:font script="Uigh" typeface="Microsoft Uighur"/>
+        <a:font script="Geor" typeface="Sylfaen"/>
+        <a:font script="Armn" typeface="Arial"/>
+        <a:font script="Bugi" typeface="Leelawadee UI"/>
+        <a:font script="Bopo" typeface="Microsoft JhengHei"/>
+        <a:font script="Java" typeface="Javanese Text"/>
+        <a:font script="Lisu" typeface="Segoe UI"/>
+        <a:font script="Mymr" typeface="Myanmar Text"/>
+        <a:font script="Nkoo" typeface="Ebrima"/>
+        <a:font script="Olck" typeface="Nirmala UI"/>
+        <a:font script="Osma" typeface="Ebrima"/>
+        <a:font script="Phag" typeface="Phagspa"/>
+        <a:font script="Syrn" typeface="Estrangelo Edessa"/>
+        <a:font script="Syrj" typeface="Estrangelo Edessa"/>
+        <a:font script="Syre" typeface="Estrangelo Edessa"/>
+        <a:font script="Sora" typeface="Nirmala UI"/>
+        <a:font script="Tale" typeface="Microsoft Tai Le"/>
+        <a:font script="Talu" typeface="Microsoft New Tai Lue"/>
+        <a:font script="Tfng" typeface="Ebrima"/>
+      </a:majorFont>
+      <a:minorFont>
+        <a:latin typeface="Aptos" panose="02110004020202020204"/>
+        <a:ea typeface=""/>
+        <a:cs typeface=""/>
+        <a:font script="Jpan" typeface="游ゴシック"/>
+        <a:font script="Hang" typeface="맑은 고딕"/>
+        <a:font script="Hans" typeface="等线"/>
+        <a:font script="Hant" typeface="新細明體"/>
+        <a:font script="Arab" typeface="Arial"/>
+        <a:font script="Hebr" typeface="Arial"/>
+        <a:font script="Thai" typeface="Cordia New"/>
+        <a:font script="Ethi" typeface="Nyala"/>
+        <a:font script="Beng" typeface="Vrinda"/>
+        <a:font script="Gujr" typeface="Shruti"/>
+        <a:font script="Khmr" typeface="DaunPenh"/>
+        <a:font script="Knda" typeface="Tunga"/>
+        <a:font script="Guru" typeface="Raavi"/>
+        <a:font script="Cans" typeface="Euphemia"/>
+        <a:font script="Cher" typeface="Plantagenet Cherokee"/>
+        <a:font script="Yiii" typeface="Microsoft Yi Baiti"/>
+        <a:font script="Tibt" typeface="Microsoft Himalaya"/>
+        <a:font script="Thaa" typeface="MV Boli"/>
+        <a:font script="Deva" typeface="Mangal"/>
+        <a:font script="Telu" typeface="Gautami"/>
+        <a:font script="Taml" typeface="Latha"/>
+        <a:font script="Syrc" typeface="Estrangelo Edessa"/>
+        <a:font script="Orya" typeface="Kalinga"/>
+        <a:font script="Mlym" typeface="Kartika"/>
+        <a:font script="Laoo" typeface="DokChampa"/>
+        <a:font script="Sinh" typeface="Iskoola Pota"/>
+        <a:font script="Mong" typeface="Mongolian Baiti"/>
+        <a:font script="Viet" typeface="Arial"/>
+        <a:font script="Uigh" typeface="Microsoft Uighur"/>
+        <a:font script="Geor" typeface="Sylfaen"/>
+        <a:font script="Armn" typeface="Arial"/>
+        <a:font script="Bugi" typeface="Leelawadee UI"/>
+        <a:font script="Bopo" typeface="Microsoft JhengHei"/>
+        <a:font script="Java" typeface="Javanese Text"/>
+        <a:font script="Lisu" typeface="Segoe UI"/>
+        <a:font script="Mymr" typeface="Myanmar Text"/>
+        <a:font script="Nkoo" typeface="Ebrima"/>
+        <a:font script="Olck" typeface="Nirmala UI"/>
+        <a:font script="Osma" typeface="Ebrima"/>
+        <a:font script="Phag" typeface="Phagspa"/>
+        <a:font script="Syrn" typeface="Estrangelo Edessa"/>
+        <a:font script="Syrj" typeface="Estrangelo Edessa"/>
+        <a:font script="Syre" typeface="Estrangelo Edessa"/>
+        <a:font script="Sora" typeface="Nirmala UI"/>
+        <a:font script="Tale" typeface="Microsoft Tai Le"/>
+        <a:font script="Talu" typeface="Microsoft New Tai Lue"/>
+        <a:font script="Tfng" typeface="Ebrima"/>
+      </a:minorFont>
+    </a:fontScheme>
+    <a:fmtScheme name="Office">
+      <a:fillStyleLst>
+        <a:solidFill>
+          <a:schemeClr val="phClr"/>
+        </a:solidFill>
+        <a:gradFill rotWithShape="1">
+          <a:gsLst>
+            <a:gs pos="0">
+              <a:schemeClr val="phClr">
+                <a:lumMod val="110000"/>
+                <a:satMod val="105000"/>
+                <a:tint val="67000"/>
+              </a:schemeClr>
+            </a:gs>
+            <a:gs pos="50000">
+              <a:schemeClr val="phClr">
+                <a:lumMod val="105000"/>
+                <a:satMod val="103000"/>
+                <a:tint val="73000"/>
+              </a:schemeClr>
+            </a:gs>
+            <a:gs pos="100000">
+              <a:schemeClr val="phClr">
+                <a:lumMod val="105000"/>
+                <a:satMod val="109000"/>
+                <a:tint val="81000"/>
+              </a:schemeClr>
+            </a:gs>
+          </a:gsLst>
+          <a:lin ang="5400000" scaled="0"/>
+        </a:gradFill>
+        <a:gradFill rotWithShape="1">
+          <a:gsLst>
+            <a:gs pos="0">
+              <a:schemeClr val="phClr">
+                <a:satMod val="103000"/>
+                <a:lumMod val="102000"/>
+                <a:tint val="94000"/>
+              </a:schemeClr>
+            </a:gs>
+            <a:gs pos="50000">
+              <a:schemeClr val="phClr">
+                <a:satMod val="110000"/>
+                <a:lumMod val="100000"/>
+                <a:shade val="100000"/>
+              </a:schemeClr>
+            </a:gs>
+            <a:gs pos="100000">
+              <a:schemeClr val="phClr">
+                <a:lumMod val="99000"/>
+                <a:satMod val="120000"/>
+                <a:shade val="78000"/>
+              </a:schemeClr>
+            </a:gs>
+          </a:gsLst>
+          <a:lin ang="5400000" scaled="0"/>
+        </a:gradFill>
+      </a:fillStyleLst>
+      <a:lnStyleLst>
+        <a:ln w="12700" cap="flat" cmpd="sng" algn="ctr">
+          <a:solidFill>
+            <a:schemeClr val="phClr"/>
+          </a:solidFill>
+          <a:prstDash val="solid"/>
+          <a:miter lim="800000"/>
+        </a:ln>
+        <a:ln w="19050" cap="flat" cmpd="sng" algn="ctr">
+          <a:solidFill>
+            <a:schemeClr val="phClr"/>
+          </a:solidFill>
+          <a:prstDash val="solid"/>
+          <a:miter lim="800000"/>
+        </a:ln>
+        <a:ln w="25400" cap="flat" cmpd="sng" algn="ctr">
+          <a:solidFill>
+            <a:schemeClr val="phClr"/>
+          </a:solidFill>
+          <a:prstDash val="solid"/>
+          <a:miter lim="800000"/>
+        </a:ln>
+      </a:lnStyleLst>
+      <a:effectStyleLst>
+        <a:effectStyle>
+          <a:effectLst/>
+        </a:effectStyle>
+        <a:effectStyle>
+          <a:effectLst/>
+        </a:effectStyle>
+        <a:effectStyle>
+          <a:effectLst>
+            <a:outerShdw blurRad="57150" dist="19050" dir="5400000" algn="ctr" rotWithShape="0">
+              <a:srgbClr val="000000">
+                <a:alpha val="63000"/>
+              </a:srgbClr>
+            </a:outerShdw>
+          </a:effectLst>
+        </a:effectStyle>
+      </a:effectStyleLst>
+      <a:bgFillStyleLst>
+        <a:solidFill>
+          <a:schemeClr val="phClr"/>
+        </a:solidFill>
+        <a:solidFill>
+          <a:schemeClr val="phClr">
+            <a:tint val="95000"/>
+            <a:satMod val="170000"/>
+          </a:schemeClr>
+        </a:solidFill>
+        <a:gradFill rotWithShape="1">
+          <a:gsLst>
+            <a:gs pos="0">
+              <a:schemeClr val="phClr">
+                <a:tint val="93000"/>
+                <a:satMod val="150000"/>
+                <a:shade val="98000"/>
+                <a:lumMod val="102000"/>
+              </a:schemeClr>
+            </a:gs>
+            <a:gs pos="50000">
+              <a:schemeClr val="phClr">
+                <a:tint val="98000"/>
+                <a:satMod val="130000"/>
+                <a:shade val="90000"/>
+                <a:lumMod val="103000"/>
+              </a:schemeClr>
+            </a:gs>
+            <a:gs pos="100000">
+              <a:schemeClr val="phClr">
+                <a:shade val="63000"/>
+                <a:satMod val="120000"/>
+              </a:schemeClr>
+            </a:gs>
+          </a:gsLst>
+          <a:lin ang="5400000" scaled="0"/>
+        </a:gradFill>
+      </a:bgFillStyleLst>
+    </a:fmtScheme>
+  </a:themeElements>
+  <a:objectDefaults>
+    <a:lnDef>
+      <a:spPr/>
+      <a:bodyPr/>
+      <a:lstStyle/>
+      <a:style>
+        <a:lnRef idx="2">
+          <a:schemeClr val="accent1"/>
+        </a:lnRef>
+        <a:fillRef idx="0">
+          <a:schemeClr val="accent1"/>
+        </a:fillRef>
+        <a:effectRef idx="1">
+          <a:schemeClr val="accent1"/>
+        </a:effectRef>
+        <a:fontRef idx="minor">
+          <a:schemeClr val="tx1"/>
+        </a:fontRef>
+      </a:style>
+    </a:lnDef>
+  </a:objectDefaults>
+  <a:extraClrSchemeLst/>
+  <a:extLst>
+    <a:ext uri="{05A4C25C-085E-4340-85A3-A5531E510DB2}">
+      <thm15:themeFamily xmlns:thm15="http://schemas.microsoft.com/office/thememl/2012/main" name="Office Theme" id="{2E142A2C-CD16-42D6-873A-C26D2A0506FA}" vid="{1BDDFF52-6CD6-40A5-AB3C-68EB2F1E4D0A}"/>
+    </a:ext>
+  </a:extLst>
+</a:theme>
 </file>
</xml_diff>